<commit_message>
Add files to uploads and downloads
</commit_message>
<xml_diff>
--- a/Teacher_Classroom_Deck_Lesson2.pptx
+++ b/Teacher_Classroom_Deck_Lesson2.pptx
@@ -4,9 +4,6 @@
   <p:sldMasterIdLst>
     <p:sldMasterId id="2147483648" r:id="rId1"/>
   </p:sldMasterIdLst>
-  <p:notesMasterIdLst>
-    <p:notesMasterId r:id="rId12"/>
-  </p:notesMasterIdLst>
   <p:sldIdLst>
     <p:sldId id="256" r:id="rId2"/>
     <p:sldId id="257" r:id="rId3"/>
@@ -19,6 +16,9 @@
     <p:sldId id="264" r:id="rId10"/>
     <p:sldId id="265" r:id="rId11"/>
   </p:sldIdLst>
+  <p:notesMasterIdLst>
+    <p:notesMasterId r:id="rId12"/>
+  </p:notesMasterIdLst>
   <p:sldSz cx="12192000" cy="6858000"/>
   <p:notesSz cx="6858000" cy="12192000"/>
   <p:defaultTextStyle>
@@ -113,11 +113,6 @@
       </a:defRPr>
     </a:lvl9pPr>
   </p:defaultTextStyle>
-  <p:extLst>
-    <p:ext uri="{EFAFB233-063F-42B5-8137-9DF3F51BA10A}">
-      <p15:sldGuideLst xmlns:p15="http://schemas.microsoft.com/office/powerpoint/2012/main"/>
-    </p:ext>
-  </p:extLst>
 </p:presentation>
 </file>
 
@@ -143,10 +138,234 @@
           <a:chExt cx="0" cy="0"/>
         </a:xfrm>
       </p:grpSpPr>
+      <p:sp>
+        <p:nvSpPr>
+          <p:cNvPr id="2" name="Header Placeholder 1"/>
+          <p:cNvSpPr>
+            <a:spLocks noGrp="1"/>
+          </p:cNvSpPr>
+          <p:nvPr>
+            <p:ph type="hdr" sz="quarter"/>
+          </p:nvPr>
+        </p:nvSpPr>
+        <p:spPr>
+          <a:xfrm>
+            <a:off x="0" y="0"/>
+            <a:ext cx="2971800" cy="458788"/>
+          </a:xfrm>
+          <a:prstGeom prst="rect">
+            <a:avLst/>
+          </a:prstGeom>
+        </p:spPr>
+        <p:txBody>
+          <a:bodyPr vert="horz" lIns="91440" tIns="45720" rIns="91440" bIns="45720" rtlCol="0"/>
+          <a:lstStyle>
+            <a:lvl1pPr algn="l">
+              <a:defRPr sz="1200"/>
+            </a:lvl1pPr>
+          </a:lstStyle>
+          <a:p>
+            <a:endParaRPr lang="en-US"/>
+          </a:p>
+        </p:txBody>
+      </p:sp>
+      <p:sp>
+        <p:nvSpPr>
+          <p:cNvPr id="3" name="Date Placeholder 2"/>
+          <p:cNvSpPr>
+            <a:spLocks noGrp="1"/>
+          </p:cNvSpPr>
+          <p:nvPr>
+            <p:ph type="dt" idx="1"/>
+          </p:nvPr>
+        </p:nvSpPr>
+        <p:spPr>
+          <a:xfrm>
+            <a:off x="3884613" y="0"/>
+            <a:ext cx="2971800" cy="458788"/>
+          </a:xfrm>
+          <a:prstGeom prst="rect">
+            <a:avLst/>
+          </a:prstGeom>
+        </p:spPr>
+        <p:txBody>
+          <a:bodyPr vert="horz" lIns="91440" tIns="45720" rIns="91440" bIns="45720" rtlCol="0"/>
+          <a:lstStyle>
+            <a:lvl1pPr algn="r">
+              <a:defRPr sz="1200"/>
+            </a:lvl1pPr>
+          </a:lstStyle>
+          <a:p>
+            <a:fld id="{5282F153-3F37-0F45-9E97-73ACFA13230C}" type="datetimeFigureOut">
+              <a:rPr lang="en-US"/>
+              <a:t>7/23/19</a:t>
+            </a:fld>
+            <a:endParaRPr lang="en-US"/>
+          </a:p>
+        </p:txBody>
+      </p:sp>
+      <p:sp>
+        <p:nvSpPr>
+          <p:cNvPr id="4" name="Slide Image Placeholder 3"/>
+          <p:cNvSpPr>
+            <a:spLocks noGrp="1" noRot="1" noChangeAspect="1"/>
+          </p:cNvSpPr>
+          <p:nvPr>
+            <p:ph type="sldImg" idx="2"/>
+          </p:nvPr>
+        </p:nvSpPr>
+        <p:spPr>
+          <a:xfrm>
+            <a:off x="685800" y="1143000"/>
+            <a:ext cx="5486400" cy="3086100"/>
+          </a:xfrm>
+          <a:prstGeom prst="rect">
+            <a:avLst/>
+          </a:prstGeom>
+          <a:noFill/>
+          <a:ln w="12700">
+            <a:solidFill>
+              <a:prstClr val="black"/>
+            </a:solidFill>
+          </a:ln>
+        </p:spPr>
+        <p:txBody>
+          <a:bodyPr vert="horz" lIns="91440" tIns="45720" rIns="91440" bIns="45720" rtlCol="0" anchor="ctr"/>
+          <a:lstStyle/>
+          <a:p>
+            <a:endParaRPr lang="en-US"/>
+          </a:p>
+        </p:txBody>
+      </p:sp>
+      <p:sp>
+        <p:nvSpPr>
+          <p:cNvPr id="5" name="Notes Placeholder 4"/>
+          <p:cNvSpPr>
+            <a:spLocks noGrp="1"/>
+          </p:cNvSpPr>
+          <p:nvPr>
+            <p:ph type="body" sz="quarter" idx="3"/>
+          </p:nvPr>
+        </p:nvSpPr>
+        <p:spPr>
+          <a:xfrm>
+            <a:off x="685800" y="4400550"/>
+            <a:ext cx="5486400" cy="3600450"/>
+          </a:xfrm>
+          <a:prstGeom prst="rect">
+            <a:avLst/>
+          </a:prstGeom>
+        </p:spPr>
+        <p:txBody>
+          <a:bodyPr vert="horz" lIns="91440" tIns="45720" rIns="91440" bIns="45720" rtlCol="0"/>
+          <a:lstStyle/>
+          <a:p>
+            <a:pPr lvl="0"/>
+            <a:r>
+              <a:rPr lang="en-US"/>
+              <a:t>Click to edit Master text styles</a:t>
+            </a:r>
+          </a:p>
+          <a:p>
+            <a:pPr lvl="1"/>
+            <a:r>
+              <a:rPr lang="en-US"/>
+              <a:t>Second level</a:t>
+            </a:r>
+          </a:p>
+          <a:p>
+            <a:pPr lvl="2"/>
+            <a:r>
+              <a:rPr lang="en-US"/>
+              <a:t>Third level</a:t>
+            </a:r>
+          </a:p>
+          <a:p>
+            <a:pPr lvl="3"/>
+            <a:r>
+              <a:rPr lang="en-US"/>
+              <a:t>Fourth level</a:t>
+            </a:r>
+          </a:p>
+          <a:p>
+            <a:pPr lvl="4"/>
+            <a:r>
+              <a:rPr lang="en-US"/>
+              <a:t>Fifth level</a:t>
+            </a:r>
+          </a:p>
+        </p:txBody>
+      </p:sp>
+      <p:sp>
+        <p:nvSpPr>
+          <p:cNvPr id="6" name="Footer Placeholder 5"/>
+          <p:cNvSpPr>
+            <a:spLocks noGrp="1"/>
+          </p:cNvSpPr>
+          <p:nvPr>
+            <p:ph type="ftr" sz="quarter" idx="4"/>
+          </p:nvPr>
+        </p:nvSpPr>
+        <p:spPr>
+          <a:xfrm>
+            <a:off x="0" y="8685213"/>
+            <a:ext cx="2971800" cy="458787"/>
+          </a:xfrm>
+          <a:prstGeom prst="rect">
+            <a:avLst/>
+          </a:prstGeom>
+        </p:spPr>
+        <p:txBody>
+          <a:bodyPr vert="horz" lIns="91440" tIns="45720" rIns="91440" bIns="45720" rtlCol="0" anchor="b"/>
+          <a:lstStyle>
+            <a:lvl1pPr algn="l">
+              <a:defRPr sz="1200"/>
+            </a:lvl1pPr>
+          </a:lstStyle>
+          <a:p>
+            <a:endParaRPr lang="en-US"/>
+          </a:p>
+        </p:txBody>
+      </p:sp>
+      <p:sp>
+        <p:nvSpPr>
+          <p:cNvPr id="7" name="Slide Number Placeholder 6"/>
+          <p:cNvSpPr>
+            <a:spLocks noGrp="1"/>
+          </p:cNvSpPr>
+          <p:nvPr>
+            <p:ph type="sldNum" sz="quarter" idx="5"/>
+          </p:nvPr>
+        </p:nvSpPr>
+        <p:spPr>
+          <a:xfrm>
+            <a:off x="3884613" y="8685213"/>
+            <a:ext cx="2971800" cy="458787"/>
+          </a:xfrm>
+          <a:prstGeom prst="rect">
+            <a:avLst/>
+          </a:prstGeom>
+        </p:spPr>
+        <p:txBody>
+          <a:bodyPr vert="horz" lIns="91440" tIns="45720" rIns="91440" bIns="45720" rtlCol="0" anchor="b"/>
+          <a:lstStyle>
+            <a:lvl1pPr algn="r">
+              <a:defRPr sz="1200"/>
+            </a:lvl1pPr>
+          </a:lstStyle>
+          <a:p>
+            <a:fld id="{CE5E9CC1-C706-0F49-92D6-E571CC5EEA8F}" type="slidenum">
+              <a:rPr lang="en-US"/>
+              <a:t>‹#›</a:t>
+            </a:fld>
+            <a:endParaRPr lang="en-US"/>
+          </a:p>
+        </p:txBody>
+      </p:sp>
     </p:spTree>
     <p:extLst>
       <p:ext uri="{BB962C8B-B14F-4D97-AF65-F5344CB8AC3E}">
-        <p14:creationId xmlns:p14="http://schemas.microsoft.com/office/powerpoint/2010/main" val="536049308"/>
+        <p14:creationId xmlns:p14="http://schemas.microsoft.com/office/powerpoint/2010/main" val="1024086991"/>
       </p:ext>
     </p:extLst>
   </p:cSld>
@@ -290,6 +509,10 @@
           <a:bodyPr/>
           <a:lstStyle/>
           <a:p>
+            <a:r>
+              <a:rPr lang="en-US" dirty="0"/>
+              <a:t/>
+            </a:r>
             <a:endParaRPr lang="en-US" dirty="0"/>
           </a:p>
         </p:txBody>
@@ -374,6 +597,10 @@
           <a:bodyPr/>
           <a:lstStyle/>
           <a:p>
+            <a:r>
+              <a:rPr lang="en-US" dirty="0"/>
+              <a:t/>
+            </a:r>
             <a:endParaRPr lang="en-US" dirty="0"/>
           </a:p>
         </p:txBody>
@@ -458,6 +685,10 @@
           <a:bodyPr/>
           <a:lstStyle/>
           <a:p>
+            <a:r>
+              <a:rPr lang="en-US" dirty="0"/>
+              <a:t/>
+            </a:r>
             <a:endParaRPr lang="en-US" dirty="0"/>
           </a:p>
         </p:txBody>
@@ -542,6 +773,10 @@
           <a:bodyPr/>
           <a:lstStyle/>
           <a:p>
+            <a:r>
+              <a:rPr lang="en-US" dirty="0"/>
+              <a:t/>
+            </a:r>
             <a:endParaRPr lang="en-US" dirty="0"/>
           </a:p>
         </p:txBody>
@@ -626,6 +861,10 @@
           <a:bodyPr/>
           <a:lstStyle/>
           <a:p>
+            <a:r>
+              <a:rPr lang="en-US" dirty="0"/>
+              <a:t/>
+            </a:r>
             <a:endParaRPr lang="en-US" dirty="0"/>
           </a:p>
         </p:txBody>
@@ -710,6 +949,10 @@
           <a:bodyPr/>
           <a:lstStyle/>
           <a:p>
+            <a:r>
+              <a:rPr lang="en-US" dirty="0"/>
+              <a:t/>
+            </a:r>
             <a:endParaRPr lang="en-US" dirty="0"/>
           </a:p>
         </p:txBody>
@@ -794,6 +1037,10 @@
           <a:bodyPr/>
           <a:lstStyle/>
           <a:p>
+            <a:r>
+              <a:rPr lang="en-US" dirty="0"/>
+              <a:t/>
+            </a:r>
             <a:endParaRPr lang="en-US" dirty="0"/>
           </a:p>
         </p:txBody>
@@ -878,6 +1125,10 @@
           <a:bodyPr/>
           <a:lstStyle/>
           <a:p>
+            <a:r>
+              <a:rPr lang="en-US" dirty="0"/>
+              <a:t/>
+            </a:r>
             <a:endParaRPr lang="en-US" dirty="0"/>
           </a:p>
         </p:txBody>
@@ -962,6 +1213,10 @@
           <a:bodyPr/>
           <a:lstStyle/>
           <a:p>
+            <a:r>
+              <a:rPr lang="en-US" dirty="0"/>
+              <a:t/>
+            </a:r>
             <a:endParaRPr lang="en-US" dirty="0"/>
           </a:p>
         </p:txBody>
@@ -1046,6 +1301,10 @@
           <a:bodyPr/>
           <a:lstStyle/>
           <a:p>
+            <a:r>
+              <a:rPr lang="en-US" dirty="0"/>
+              <a:t/>
+            </a:r>
             <a:endParaRPr lang="en-US" dirty="0"/>
           </a:p>
         </p:txBody>
@@ -1119,11 +1378,6 @@
 <file path=ppt/slideMasters/slideMaster1.xml><?xml version="1.0" encoding="utf-8"?>
 <p:sldMaster xmlns:a="http://schemas.openxmlformats.org/drawingml/2006/main" xmlns:r="http://schemas.openxmlformats.org/officeDocument/2006/relationships" xmlns:p="http://schemas.openxmlformats.org/presentationml/2006/main">
   <p:cSld>
-    <p:bg>
-      <p:bgRef idx="1001">
-        <a:schemeClr val="bg1"/>
-      </p:bgRef>
-    </p:bg>
     <p:spTree>
       <p:nvGrpSpPr>
         <p:cNvPr id="1" name=""/>
@@ -1406,7 +1660,6 @@
         <a:solidFill>
           <a:srgbClr val="1A3A5C"/>
         </a:solidFill>
-        <a:effectLst/>
       </p:bgPr>
     </p:bg>
     <p:spTree>
@@ -1449,13 +1702,6 @@
             <a:prstDash val="solid"/>
           </a:ln>
         </p:spPr>
-        <p:txBody>
-          <a:bodyPr/>
-          <a:lstStyle/>
-          <a:p>
-            <a:endParaRPr lang="en-US"/>
-          </a:p>
-        </p:txBody>
       </p:sp>
       <p:sp>
         <p:nvSpPr>
@@ -1483,13 +1729,6 @@
             <a:prstDash val="solid"/>
           </a:ln>
         </p:spPr>
-        <p:txBody>
-          <a:bodyPr/>
-          <a:lstStyle/>
-          <a:p>
-            <a:endParaRPr lang="en-US"/>
-          </a:p>
-        </p:txBody>
       </p:sp>
       <p:sp>
         <p:nvSpPr>
@@ -1517,13 +1756,6 @@
             <a:prstDash val="solid"/>
           </a:ln>
         </p:spPr>
-        <p:txBody>
-          <a:bodyPr/>
-          <a:lstStyle/>
-          <a:p>
-            <a:endParaRPr lang="en-US"/>
-          </a:p>
-        </p:txBody>
       </p:sp>
       <p:sp>
         <p:nvSpPr>
@@ -1546,7 +1778,7 @@
           <a:bodyPr wrap="square" rtlCol="0" anchor="ctr"/>
           <a:lstStyle/>
           <a:p>
-            <a:pPr marL="0" indent="0" algn="ctr">
+            <a:pPr algn="ctr" indent="0" marL="0">
               <a:buNone/>
             </a:pPr>
             <a:r>
@@ -1585,7 +1817,7 @@
           <a:bodyPr wrap="square" rtlCol="0" anchor="ctr"/>
           <a:lstStyle/>
           <a:p>
-            <a:pPr marL="0" indent="0">
+            <a:pPr indent="0" marL="0">
               <a:lnSpc>
                 <a:spcPct val="95000"/>
               </a:lnSpc>
@@ -1605,7 +1837,7 @@
             <a:endParaRPr lang="en-US" sz="5200" dirty="0"/>
           </a:p>
           <a:p>
-            <a:pPr marL="0" indent="0">
+            <a:pPr indent="0" marL="0">
               <a:lnSpc>
                 <a:spcPct val="95000"/>
               </a:lnSpc>
@@ -1647,7 +1879,7 @@
           <a:bodyPr wrap="square" rtlCol="0" anchor="ctr"/>
           <a:lstStyle/>
           <a:p>
-            <a:pPr marL="0" indent="0">
+            <a:pPr indent="0" marL="0">
               <a:buNone/>
             </a:pPr>
             <a:r>
@@ -1695,13 +1927,6 @@
             <a:prstDash val="solid"/>
           </a:ln>
         </p:spPr>
-        <p:txBody>
-          <a:bodyPr/>
-          <a:lstStyle/>
-          <a:p>
-            <a:endParaRPr lang="en-US"/>
-          </a:p>
-        </p:txBody>
       </p:sp>
       <p:sp>
         <p:nvSpPr>
@@ -1724,7 +1949,7 @@
           <a:bodyPr wrap="square" rtlCol="0" anchor="ctr"/>
           <a:lstStyle/>
           <a:p>
-            <a:pPr marL="0" indent="0" algn="ctr">
+            <a:pPr algn="ctr" indent="0" marL="0">
               <a:buNone/>
             </a:pPr>
             <a:r>
@@ -1772,13 +1997,6 @@
             <a:prstDash val="solid"/>
           </a:ln>
         </p:spPr>
-        <p:txBody>
-          <a:bodyPr/>
-          <a:lstStyle/>
-          <a:p>
-            <a:endParaRPr lang="en-US"/>
-          </a:p>
-        </p:txBody>
       </p:sp>
       <p:sp>
         <p:nvSpPr>
@@ -1801,7 +2019,7 @@
           <a:bodyPr wrap="square" rtlCol="0" anchor="ctr"/>
           <a:lstStyle/>
           <a:p>
-            <a:pPr marL="0" indent="0" algn="ctr">
+            <a:pPr algn="ctr" indent="0" marL="0">
               <a:buNone/>
             </a:pPr>
             <a:r>
@@ -1849,13 +2067,6 @@
             <a:prstDash val="solid"/>
           </a:ln>
         </p:spPr>
-        <p:txBody>
-          <a:bodyPr/>
-          <a:lstStyle/>
-          <a:p>
-            <a:endParaRPr lang="en-US"/>
-          </a:p>
-        </p:txBody>
       </p:sp>
       <p:sp>
         <p:nvSpPr>
@@ -1878,7 +2089,7 @@
           <a:bodyPr wrap="square" rtlCol="0" anchor="ctr"/>
           <a:lstStyle/>
           <a:p>
-            <a:pPr marL="0" indent="0" algn="ctr">
+            <a:pPr algn="ctr" indent="0" marL="0">
               <a:buNone/>
             </a:pPr>
             <a:r>
@@ -1917,7 +2128,7 @@
           <a:bodyPr wrap="square" rtlCol="0" anchor="ctr"/>
           <a:lstStyle/>
           <a:p>
-            <a:pPr marL="0" indent="0" algn="ctr">
+            <a:pPr algn="ctr" indent="0" marL="0">
               <a:buNone/>
             </a:pPr>
             <a:r>
@@ -1951,7 +2162,6 @@
         <a:solidFill>
           <a:srgbClr val="1A3A5C"/>
         </a:solidFill>
-        <a:effectLst/>
       </p:bgPr>
     </p:bg>
     <p:spTree>
@@ -1994,13 +2204,6 @@
             <a:prstDash val="solid"/>
           </a:ln>
         </p:spPr>
-        <p:txBody>
-          <a:bodyPr/>
-          <a:lstStyle/>
-          <a:p>
-            <a:endParaRPr lang="en-US"/>
-          </a:p>
-        </p:txBody>
       </p:sp>
       <p:sp>
         <p:nvSpPr>
@@ -2023,11 +2226,11 @@
           <a:bodyPr wrap="square" rtlCol="0" anchor="ctr"/>
           <a:lstStyle/>
           <a:p>
-            <a:pPr marL="0" indent="0">
-              <a:buNone/>
-            </a:pPr>
-            <a:r>
-              <a:rPr lang="en-US" sz="850" b="1" kern="0" spc="300" dirty="0">
+            <a:pPr indent="0" marL="0">
+              <a:buNone/>
+            </a:pPr>
+            <a:r>
+              <a:rPr lang="en-US" sz="850" b="1" spc="300" kern="0" dirty="0">
                 <a:solidFill>
                   <a:srgbClr val="94A3B8"/>
                 </a:solidFill>
@@ -2062,7 +2265,7 @@
           <a:bodyPr wrap="square" rtlCol="0" anchor="ctr"/>
           <a:lstStyle/>
           <a:p>
-            <a:pPr marL="0" indent="0">
+            <a:pPr indent="0" marL="0">
               <a:buNone/>
             </a:pPr>
             <a:r>
@@ -2104,13 +2307,6 @@
             <a:prstDash val="solid"/>
           </a:ln>
         </p:spPr>
-        <p:txBody>
-          <a:bodyPr/>
-          <a:lstStyle/>
-          <a:p>
-            <a:endParaRPr lang="en-US"/>
-          </a:p>
-        </p:txBody>
       </p:sp>
       <p:sp>
         <p:nvSpPr>
@@ -2138,13 +2334,6 @@
             <a:prstDash val="solid"/>
           </a:ln>
         </p:spPr>
-        <p:txBody>
-          <a:bodyPr/>
-          <a:lstStyle/>
-          <a:p>
-            <a:endParaRPr lang="en-US"/>
-          </a:p>
-        </p:txBody>
       </p:sp>
       <p:sp>
         <p:nvSpPr>
@@ -2167,11 +2356,11 @@
           <a:bodyPr wrap="square" rtlCol="0" anchor="ctr"/>
           <a:lstStyle/>
           <a:p>
-            <a:pPr marL="0" indent="0">
-              <a:buNone/>
-            </a:pPr>
-            <a:r>
-              <a:rPr lang="en-US" sz="850" b="1" kern="0" spc="200" dirty="0">
+            <a:pPr indent="0" marL="0">
+              <a:buNone/>
+            </a:pPr>
+            <a:r>
+              <a:rPr lang="en-US" sz="850" b="1" spc="200" kern="0" dirty="0">
                 <a:solidFill>
                   <a:srgbClr val="F0A500"/>
                 </a:solidFill>
@@ -2211,13 +2400,6 @@
             <a:prstDash val="solid"/>
           </a:ln>
         </p:spPr>
-        <p:txBody>
-          <a:bodyPr/>
-          <a:lstStyle/>
-          <a:p>
-            <a:endParaRPr lang="en-US" dirty="0"/>
-          </a:p>
-        </p:txBody>
       </p:sp>
       <p:sp>
         <p:nvSpPr>
@@ -2227,7 +2409,7 @@
         </p:nvSpPr>
         <p:spPr>
           <a:xfrm>
-            <a:off x="626364" y="2002536"/>
+            <a:off x="612648" y="2144268"/>
             <a:ext cx="329184" cy="329184"/>
           </a:xfrm>
           <a:prstGeom prst="ellipse">
@@ -2243,13 +2425,6 @@
             <a:prstDash val="solid"/>
           </a:ln>
         </p:spPr>
-        <p:txBody>
-          <a:bodyPr/>
-          <a:lstStyle/>
-          <a:p>
-            <a:endParaRPr lang="en-US"/>
-          </a:p>
-        </p:txBody>
       </p:sp>
       <p:sp>
         <p:nvSpPr>
@@ -2259,26 +2434,26 @@
         </p:nvSpPr>
         <p:spPr>
           <a:xfrm>
-            <a:off x="589202" y="2011210"/>
-            <a:ext cx="411480" cy="329184"/>
-          </a:xfrm>
-          <a:prstGeom prst="rect">
-            <a:avLst/>
-          </a:prstGeom>
-          <a:noFill/>
-          <a:ln/>
-        </p:spPr>
-        <p:txBody>
-          <a:bodyPr wrap="square" rtlCol="0" anchor="ctr"/>
-          <a:lstStyle/>
-          <a:p>
-            <a:pPr marL="0" indent="0" algn="ctr">
+            <a:off x="612648" y="1847088"/>
+            <a:ext cx="329184" cy="329184"/>
+          </a:xfrm>
+          <a:prstGeom prst="rect">
+            <a:avLst/>
+          </a:prstGeom>
+          <a:noFill/>
+          <a:ln/>
+        </p:spPr>
+        <p:txBody>
+          <a:bodyPr wrap="square" rtlCol="0" anchor="ctr"/>
+          <a:lstStyle/>
+          <a:p>
+            <a:pPr algn="ctr" indent="0" marL="0">
               <a:buNone/>
             </a:pPr>
             <a:r>
               <a:rPr lang="en-US" sz="1100" b="1" dirty="0">
                 <a:solidFill>
-                  <a:srgbClr val="0E7C86"/>
+                  <a:srgbClr val="F0A500"/>
                 </a:solidFill>
                 <a:latin typeface="Calibri" pitchFamily="34" charset="0"/>
                 <a:ea typeface="Calibri" pitchFamily="34" charset="-122"/>
@@ -2286,11 +2461,7 @@
               </a:rPr>
               <a:t>Q1</a:t>
             </a:r>
-            <a:endParaRPr lang="en-US" sz="1100" dirty="0">
-              <a:solidFill>
-                <a:srgbClr val="0E7C86"/>
-              </a:solidFill>
-            </a:endParaRPr>
+            <a:endParaRPr lang="en-US" sz="1100" dirty="0"/>
           </a:p>
         </p:txBody>
       </p:sp>
@@ -2315,7 +2486,7 @@
           <a:bodyPr wrap="square" rtlCol="0" anchor="ctr"/>
           <a:lstStyle/>
           <a:p>
-            <a:pPr marL="0" indent="0">
+            <a:pPr indent="0" marL="0">
               <a:buNone/>
             </a:pPr>
             <a:r>
@@ -2361,13 +2532,6 @@
             <a:prstDash val="solid"/>
           </a:ln>
         </p:spPr>
-        <p:txBody>
-          <a:bodyPr/>
-          <a:lstStyle/>
-          <a:p>
-            <a:endParaRPr lang="en-US"/>
-          </a:p>
-        </p:txBody>
       </p:sp>
       <p:sp>
         <p:nvSpPr>
@@ -2390,7 +2554,7 @@
           <a:bodyPr wrap="square" rtlCol="0" anchor="ctr"/>
           <a:lstStyle/>
           <a:p>
-            <a:pPr marL="0" indent="0" algn="ctr">
+            <a:pPr algn="ctr" indent="0" marL="0">
               <a:buNone/>
             </a:pPr>
             <a:r>
@@ -2434,13 +2598,6 @@
             <a:prstDash val="solid"/>
           </a:ln>
         </p:spPr>
-        <p:txBody>
-          <a:bodyPr/>
-          <a:lstStyle/>
-          <a:p>
-            <a:endParaRPr lang="en-US"/>
-          </a:p>
-        </p:txBody>
       </p:sp>
       <p:sp>
         <p:nvSpPr>
@@ -2450,7 +2607,7 @@
         </p:nvSpPr>
         <p:spPr>
           <a:xfrm>
-            <a:off x="659540" y="3227481"/>
+            <a:off x="612648" y="3332988"/>
             <a:ext cx="329184" cy="329184"/>
           </a:xfrm>
           <a:prstGeom prst="ellipse">
@@ -2466,13 +2623,6 @@
             <a:prstDash val="solid"/>
           </a:ln>
         </p:spPr>
-        <p:txBody>
-          <a:bodyPr/>
-          <a:lstStyle/>
-          <a:p>
-            <a:endParaRPr lang="en-US"/>
-          </a:p>
-        </p:txBody>
       </p:sp>
       <p:sp>
         <p:nvSpPr>
@@ -2482,26 +2632,26 @@
         </p:nvSpPr>
         <p:spPr>
           <a:xfrm>
-            <a:off x="612648" y="3223376"/>
-            <a:ext cx="411480" cy="329184"/>
-          </a:xfrm>
-          <a:prstGeom prst="rect">
-            <a:avLst/>
-          </a:prstGeom>
-          <a:noFill/>
-          <a:ln/>
-        </p:spPr>
-        <p:txBody>
-          <a:bodyPr wrap="square" rtlCol="0" anchor="ctr"/>
-          <a:lstStyle/>
-          <a:p>
-            <a:pPr marL="0" indent="0" algn="ctr">
+            <a:off x="612648" y="3035808"/>
+            <a:ext cx="329184" cy="329184"/>
+          </a:xfrm>
+          <a:prstGeom prst="rect">
+            <a:avLst/>
+          </a:prstGeom>
+          <a:noFill/>
+          <a:ln/>
+        </p:spPr>
+        <p:txBody>
+          <a:bodyPr wrap="square" rtlCol="0" anchor="ctr"/>
+          <a:lstStyle/>
+          <a:p>
+            <a:pPr algn="ctr" indent="0" marL="0">
               <a:buNone/>
             </a:pPr>
             <a:r>
               <a:rPr lang="en-US" sz="1100" b="1" dirty="0">
                 <a:solidFill>
-                  <a:srgbClr val="0E7C86"/>
+                  <a:srgbClr val="F0A500"/>
                 </a:solidFill>
                 <a:latin typeface="Calibri" pitchFamily="34" charset="0"/>
                 <a:ea typeface="Calibri" pitchFamily="34" charset="-122"/>
@@ -2509,11 +2659,7 @@
               </a:rPr>
               <a:t>Q2</a:t>
             </a:r>
-            <a:endParaRPr lang="en-US" sz="1100" dirty="0">
-              <a:solidFill>
-                <a:srgbClr val="0E7C86"/>
-              </a:solidFill>
-            </a:endParaRPr>
+            <a:endParaRPr lang="en-US" sz="1100" dirty="0"/>
           </a:p>
         </p:txBody>
       </p:sp>
@@ -2538,7 +2684,7 @@
           <a:bodyPr wrap="square" rtlCol="0" anchor="ctr"/>
           <a:lstStyle/>
           <a:p>
-            <a:pPr marL="0" indent="0">
+            <a:pPr indent="0" marL="0">
               <a:buNone/>
             </a:pPr>
             <a:r>
@@ -2584,13 +2730,6 @@
             <a:prstDash val="solid"/>
           </a:ln>
         </p:spPr>
-        <p:txBody>
-          <a:bodyPr/>
-          <a:lstStyle/>
-          <a:p>
-            <a:endParaRPr lang="en-US"/>
-          </a:p>
-        </p:txBody>
       </p:sp>
       <p:sp>
         <p:nvSpPr>
@@ -2613,7 +2752,7 @@
           <a:bodyPr wrap="square" rtlCol="0" anchor="ctr"/>
           <a:lstStyle/>
           <a:p>
-            <a:pPr marL="0" indent="0" algn="ctr">
+            <a:pPr algn="ctr" indent="0" marL="0">
               <a:buNone/>
             </a:pPr>
             <a:r>
@@ -2657,13 +2796,6 @@
             <a:prstDash val="solid"/>
           </a:ln>
         </p:spPr>
-        <p:txBody>
-          <a:bodyPr/>
-          <a:lstStyle/>
-          <a:p>
-            <a:endParaRPr lang="en-US"/>
-          </a:p>
-        </p:txBody>
       </p:sp>
       <p:sp>
         <p:nvSpPr>
@@ -2673,7 +2805,7 @@
         </p:nvSpPr>
         <p:spPr>
           <a:xfrm>
-            <a:off x="647817" y="4416201"/>
+            <a:off x="612648" y="4521708"/>
             <a:ext cx="329184" cy="329184"/>
           </a:xfrm>
           <a:prstGeom prst="ellipse">
@@ -2689,13 +2821,6 @@
             <a:prstDash val="solid"/>
           </a:ln>
         </p:spPr>
-        <p:txBody>
-          <a:bodyPr/>
-          <a:lstStyle/>
-          <a:p>
-            <a:endParaRPr lang="en-US"/>
-          </a:p>
-        </p:txBody>
       </p:sp>
       <p:sp>
         <p:nvSpPr>
@@ -2705,26 +2830,26 @@
         </p:nvSpPr>
         <p:spPr>
           <a:xfrm>
-            <a:off x="612648" y="4400373"/>
-            <a:ext cx="411480" cy="329184"/>
-          </a:xfrm>
-          <a:prstGeom prst="rect">
-            <a:avLst/>
-          </a:prstGeom>
-          <a:noFill/>
-          <a:ln/>
-        </p:spPr>
-        <p:txBody>
-          <a:bodyPr wrap="square" rtlCol="0" anchor="ctr"/>
-          <a:lstStyle/>
-          <a:p>
-            <a:pPr marL="0" indent="0" algn="ctr">
+            <a:off x="612648" y="4224528"/>
+            <a:ext cx="329184" cy="329184"/>
+          </a:xfrm>
+          <a:prstGeom prst="rect">
+            <a:avLst/>
+          </a:prstGeom>
+          <a:noFill/>
+          <a:ln/>
+        </p:spPr>
+        <p:txBody>
+          <a:bodyPr wrap="square" rtlCol="0" anchor="ctr"/>
+          <a:lstStyle/>
+          <a:p>
+            <a:pPr algn="ctr" indent="0" marL="0">
               <a:buNone/>
             </a:pPr>
             <a:r>
               <a:rPr lang="en-US" sz="1100" b="1" dirty="0">
                 <a:solidFill>
-                  <a:srgbClr val="0E7C86"/>
+                  <a:srgbClr val="F0A500"/>
                 </a:solidFill>
                 <a:latin typeface="Calibri" pitchFamily="34" charset="0"/>
                 <a:ea typeface="Calibri" pitchFamily="34" charset="-122"/>
@@ -2732,11 +2857,7 @@
               </a:rPr>
               <a:t>Q3</a:t>
             </a:r>
-            <a:endParaRPr lang="en-US" sz="1100" dirty="0">
-              <a:solidFill>
-                <a:srgbClr val="0E7C86"/>
-              </a:solidFill>
-            </a:endParaRPr>
+            <a:endParaRPr lang="en-US" sz="1100" dirty="0"/>
           </a:p>
         </p:txBody>
       </p:sp>
@@ -2761,7 +2882,7 @@
           <a:bodyPr wrap="square" rtlCol="0" anchor="ctr"/>
           <a:lstStyle/>
           <a:p>
-            <a:pPr marL="0" indent="0">
+            <a:pPr indent="0" marL="0">
               <a:buNone/>
             </a:pPr>
             <a:r>
@@ -2807,13 +2928,6 @@
             <a:prstDash val="solid"/>
           </a:ln>
         </p:spPr>
-        <p:txBody>
-          <a:bodyPr/>
-          <a:lstStyle/>
-          <a:p>
-            <a:endParaRPr lang="en-US"/>
-          </a:p>
-        </p:txBody>
       </p:sp>
       <p:sp>
         <p:nvSpPr>
@@ -2836,7 +2950,7 @@
           <a:bodyPr wrap="square" rtlCol="0" anchor="ctr"/>
           <a:lstStyle/>
           <a:p>
-            <a:pPr marL="0" indent="0" algn="ctr">
+            <a:pPr algn="ctr" indent="0" marL="0">
               <a:buNone/>
             </a:pPr>
             <a:r>
@@ -2880,13 +2994,6 @@
             <a:prstDash val="solid"/>
           </a:ln>
         </p:spPr>
-        <p:txBody>
-          <a:bodyPr/>
-          <a:lstStyle/>
-          <a:p>
-            <a:endParaRPr lang="en-US"/>
-          </a:p>
-        </p:txBody>
       </p:sp>
       <p:sp>
         <p:nvSpPr>
@@ -2909,11 +3016,11 @@
           <a:bodyPr wrap="square" rtlCol="0" anchor="ctr"/>
           <a:lstStyle/>
           <a:p>
-            <a:pPr marL="0" indent="0">
-              <a:buNone/>
-            </a:pPr>
-            <a:r>
-              <a:rPr lang="en-US" sz="850" b="1" kern="0" spc="200" dirty="0">
+            <a:pPr indent="0" marL="0">
+              <a:buNone/>
+            </a:pPr>
+            <a:r>
+              <a:rPr lang="en-US" sz="850" b="1" spc="200" kern="0" dirty="0">
                 <a:solidFill>
                   <a:srgbClr val="0E7C86"/>
                 </a:solidFill>
@@ -2951,13 +3058,6 @@
             <a:prstDash val="solid"/>
           </a:ln>
         </p:spPr>
-        <p:txBody>
-          <a:bodyPr/>
-          <a:lstStyle/>
-          <a:p>
-            <a:endParaRPr lang="en-US"/>
-          </a:p>
-        </p:txBody>
       </p:sp>
       <p:sp>
         <p:nvSpPr>
@@ -2980,7 +3080,7 @@
           <a:bodyPr wrap="square" rtlCol="0" anchor="ctr"/>
           <a:lstStyle/>
           <a:p>
-            <a:pPr marL="0" indent="0">
+            <a:pPr indent="0" marL="0">
               <a:buNone/>
             </a:pPr>
             <a:r>
@@ -3022,13 +3122,6 @@
             <a:prstDash val="solid"/>
           </a:ln>
         </p:spPr>
-        <p:txBody>
-          <a:bodyPr/>
-          <a:lstStyle/>
-          <a:p>
-            <a:endParaRPr lang="en-US"/>
-          </a:p>
-        </p:txBody>
       </p:sp>
       <p:sp>
         <p:nvSpPr>
@@ -3051,7 +3144,7 @@
           <a:bodyPr wrap="square" rtlCol="0" anchor="ctr"/>
           <a:lstStyle/>
           <a:p>
-            <a:pPr marL="0" indent="0">
+            <a:pPr indent="0" marL="0">
               <a:buNone/>
             </a:pPr>
             <a:r>
@@ -3093,13 +3186,6 @@
             <a:prstDash val="solid"/>
           </a:ln>
         </p:spPr>
-        <p:txBody>
-          <a:bodyPr/>
-          <a:lstStyle/>
-          <a:p>
-            <a:endParaRPr lang="en-US"/>
-          </a:p>
-        </p:txBody>
       </p:sp>
       <p:sp>
         <p:nvSpPr>
@@ -3122,7 +3208,7 @@
           <a:bodyPr wrap="square" rtlCol="0" anchor="ctr"/>
           <a:lstStyle/>
           <a:p>
-            <a:pPr marL="0" indent="0">
+            <a:pPr indent="0" marL="0">
               <a:buNone/>
             </a:pPr>
             <a:r>
@@ -3166,13 +3252,6 @@
             <a:prstDash val="solid"/>
           </a:ln>
         </p:spPr>
-        <p:txBody>
-          <a:bodyPr/>
-          <a:lstStyle/>
-          <a:p>
-            <a:endParaRPr lang="en-US"/>
-          </a:p>
-        </p:txBody>
       </p:sp>
       <p:sp>
         <p:nvSpPr>
@@ -3195,11 +3274,11 @@
           <a:bodyPr wrap="square" rtlCol="0" anchor="ctr"/>
           <a:lstStyle/>
           <a:p>
-            <a:pPr marL="0" indent="0">
-              <a:buNone/>
-            </a:pPr>
-            <a:r>
-              <a:rPr lang="en-US" sz="850" b="1" kern="0" spc="200" dirty="0">
+            <a:pPr indent="0" marL="0">
+              <a:buNone/>
+            </a:pPr>
+            <a:r>
+              <a:rPr lang="en-US" sz="850" b="1" spc="200" kern="0" dirty="0">
                 <a:solidFill>
                   <a:srgbClr val="C8102E"/>
                 </a:solidFill>
@@ -3234,7 +3313,7 @@
           <a:bodyPr wrap="square" rtlCol="0" anchor="ctr"/>
           <a:lstStyle/>
           <a:p>
-            <a:pPr marL="0" indent="0">
+            <a:pPr indent="0" marL="0">
               <a:buNone/>
             </a:pPr>
             <a:r>
@@ -3273,7 +3352,7 @@
           <a:bodyPr wrap="square" rtlCol="0" anchor="ctr"/>
           <a:lstStyle/>
           <a:p>
-            <a:pPr marL="0" indent="0" algn="ctr">
+            <a:pPr algn="ctr" indent="0" marL="0">
               <a:buNone/>
             </a:pPr>
             <a:r>
@@ -3307,7 +3386,6 @@
         <a:solidFill>
           <a:srgbClr val="FFFFFF"/>
         </a:solidFill>
-        <a:effectLst/>
       </p:bgPr>
     </p:bg>
     <p:spTree>
@@ -3345,11 +3423,11 @@
           <a:bodyPr wrap="square" rtlCol="0" anchor="ctr"/>
           <a:lstStyle/>
           <a:p>
-            <a:pPr marL="0" indent="0">
-              <a:buNone/>
-            </a:pPr>
-            <a:r>
-              <a:rPr lang="en-US" sz="850" b="1" kern="0" spc="300" dirty="0">
+            <a:pPr indent="0" marL="0">
+              <a:buNone/>
+            </a:pPr>
+            <a:r>
+              <a:rPr lang="en-US" sz="850" b="1" spc="300" kern="0" dirty="0">
                 <a:solidFill>
                   <a:srgbClr val="0E7C86"/>
                 </a:solidFill>
@@ -3384,7 +3462,7 @@
           <a:bodyPr wrap="square" rtlCol="0" anchor="ctr"/>
           <a:lstStyle/>
           <a:p>
-            <a:pPr marL="0" indent="0">
+            <a:pPr indent="0" marL="0">
               <a:buNone/>
             </a:pPr>
             <a:r>
@@ -3423,7 +3501,7 @@
           <a:bodyPr wrap="square" rtlCol="0" anchor="ctr"/>
           <a:lstStyle/>
           <a:p>
-            <a:pPr marL="0" indent="0">
+            <a:pPr indent="0" marL="0">
               <a:buNone/>
             </a:pPr>
             <a:r>
@@ -3467,13 +3545,6 @@
             <a:prstDash val="solid"/>
           </a:ln>
         </p:spPr>
-        <p:txBody>
-          <a:bodyPr/>
-          <a:lstStyle/>
-          <a:p>
-            <a:endParaRPr lang="en-US"/>
-          </a:p>
-        </p:txBody>
       </p:sp>
       <p:sp>
         <p:nvSpPr>
@@ -3499,13 +3570,6 @@
             <a:prstDash val="solid"/>
           </a:ln>
         </p:spPr>
-        <p:txBody>
-          <a:bodyPr/>
-          <a:lstStyle/>
-          <a:p>
-            <a:endParaRPr lang="en-US"/>
-          </a:p>
-        </p:txBody>
       </p:sp>
       <p:sp>
         <p:nvSpPr>
@@ -3528,7 +3592,7 @@
           <a:bodyPr wrap="square" rtlCol="0" anchor="ctr"/>
           <a:lstStyle/>
           <a:p>
-            <a:pPr marL="0" indent="0" algn="ctr">
+            <a:pPr algn="ctr" indent="0" marL="0">
               <a:buNone/>
             </a:pPr>
             <a:r>
@@ -3567,7 +3631,7 @@
           <a:bodyPr wrap="square" rtlCol="0" anchor="ctr"/>
           <a:lstStyle/>
           <a:p>
-            <a:pPr marL="0" indent="0">
+            <a:pPr indent="0" marL="0">
               <a:buNone/>
             </a:pPr>
             <a:r>
@@ -3611,13 +3675,6 @@
             <a:prstDash val="solid"/>
           </a:ln>
         </p:spPr>
-        <p:txBody>
-          <a:bodyPr/>
-          <a:lstStyle/>
-          <a:p>
-            <a:endParaRPr lang="en-US"/>
-          </a:p>
-        </p:txBody>
       </p:sp>
       <p:sp>
         <p:nvSpPr>
@@ -3643,13 +3700,6 @@
             <a:prstDash val="solid"/>
           </a:ln>
         </p:spPr>
-        <p:txBody>
-          <a:bodyPr/>
-          <a:lstStyle/>
-          <a:p>
-            <a:endParaRPr lang="en-US"/>
-          </a:p>
-        </p:txBody>
       </p:sp>
       <p:sp>
         <p:nvSpPr>
@@ -3672,7 +3722,7 @@
           <a:bodyPr wrap="square" rtlCol="0" anchor="ctr"/>
           <a:lstStyle/>
           <a:p>
-            <a:pPr marL="0" indent="0" algn="ctr">
+            <a:pPr algn="ctr" indent="0" marL="0">
               <a:buNone/>
             </a:pPr>
             <a:r>
@@ -3711,7 +3761,7 @@
           <a:bodyPr wrap="square" rtlCol="0" anchor="ctr"/>
           <a:lstStyle/>
           <a:p>
-            <a:pPr marL="0" indent="0">
+            <a:pPr indent="0" marL="0">
               <a:buNone/>
             </a:pPr>
             <a:r>
@@ -3755,13 +3805,6 @@
             <a:prstDash val="solid"/>
           </a:ln>
         </p:spPr>
-        <p:txBody>
-          <a:bodyPr/>
-          <a:lstStyle/>
-          <a:p>
-            <a:endParaRPr lang="en-US"/>
-          </a:p>
-        </p:txBody>
       </p:sp>
       <p:sp>
         <p:nvSpPr>
@@ -3789,13 +3832,6 @@
             <a:prstDash val="solid"/>
           </a:ln>
         </p:spPr>
-        <p:txBody>
-          <a:bodyPr/>
-          <a:lstStyle/>
-          <a:p>
-            <a:endParaRPr lang="en-US"/>
-          </a:p>
-        </p:txBody>
       </p:sp>
       <p:sp>
         <p:nvSpPr>
@@ -3818,7 +3854,7 @@
           <a:bodyPr wrap="square" rtlCol="0" anchor="ctr"/>
           <a:lstStyle/>
           <a:p>
-            <a:pPr marL="0" indent="0" algn="ctr">
+            <a:pPr algn="ctr" indent="0" marL="0">
               <a:buNone/>
             </a:pPr>
             <a:r>
@@ -3857,7 +3893,7 @@
           <a:bodyPr wrap="square" rtlCol="0" anchor="ctr"/>
           <a:lstStyle/>
           <a:p>
-            <a:pPr marL="0" indent="0" algn="ctr">
+            <a:pPr algn="ctr" indent="0" marL="0">
               <a:buNone/>
             </a:pPr>
             <a:r>
@@ -3896,7 +3932,7 @@
           <a:bodyPr wrap="square" rtlCol="0" anchor="ctr"/>
           <a:lstStyle/>
           <a:p>
-            <a:pPr marL="0" indent="0" algn="ctr">
+            <a:pPr algn="ctr" indent="0" marL="0">
               <a:buNone/>
             </a:pPr>
             <a:r>
@@ -3930,7 +3966,6 @@
         <a:solidFill>
           <a:srgbClr val="FFFFFF"/>
         </a:solidFill>
-        <a:effectLst/>
       </p:bgPr>
     </p:bg>
     <p:spTree>
@@ -3968,11 +4003,11 @@
           <a:bodyPr wrap="square" rtlCol="0" anchor="ctr"/>
           <a:lstStyle/>
           <a:p>
-            <a:pPr marL="0" indent="0">
-              <a:buNone/>
-            </a:pPr>
-            <a:r>
-              <a:rPr lang="en-US" sz="850" b="1" kern="0" spc="300" dirty="0">
+            <a:pPr indent="0" marL="0">
+              <a:buNone/>
+            </a:pPr>
+            <a:r>
+              <a:rPr lang="en-US" sz="850" b="1" spc="300" kern="0" dirty="0">
                 <a:solidFill>
                   <a:srgbClr val="0E7C86"/>
                 </a:solidFill>
@@ -4007,7 +4042,7 @@
           <a:bodyPr wrap="square" rtlCol="0" anchor="ctr"/>
           <a:lstStyle/>
           <a:p>
-            <a:pPr marL="0" indent="0">
+            <a:pPr indent="0" marL="0">
               <a:buNone/>
             </a:pPr>
             <a:r>
@@ -4051,13 +4086,6 @@
             <a:prstDash val="solid"/>
           </a:ln>
         </p:spPr>
-        <p:txBody>
-          <a:bodyPr/>
-          <a:lstStyle/>
-          <a:p>
-            <a:endParaRPr lang="en-US"/>
-          </a:p>
-        </p:txBody>
       </p:sp>
       <p:sp>
         <p:nvSpPr>
@@ -4083,13 +4111,6 @@
             <a:prstDash val="solid"/>
           </a:ln>
         </p:spPr>
-        <p:txBody>
-          <a:bodyPr/>
-          <a:lstStyle/>
-          <a:p>
-            <a:endParaRPr lang="en-US"/>
-          </a:p>
-        </p:txBody>
       </p:sp>
       <p:sp>
         <p:nvSpPr>
@@ -4112,7 +4133,7 @@
           <a:bodyPr wrap="square" rtlCol="0" anchor="ctr"/>
           <a:lstStyle/>
           <a:p>
-            <a:pPr marL="0" indent="0" algn="ctr">
+            <a:pPr algn="ctr" indent="0" marL="0">
               <a:buNone/>
             </a:pPr>
             <a:r>
@@ -4151,7 +4172,7 @@
           <a:bodyPr wrap="square" rtlCol="0" anchor="ctr"/>
           <a:lstStyle/>
           <a:p>
-            <a:pPr marL="0" indent="0">
+            <a:pPr indent="0" marL="0">
               <a:buNone/>
             </a:pPr>
             <a:r>
@@ -4195,13 +4216,6 @@
             <a:prstDash val="solid"/>
           </a:ln>
         </p:spPr>
-        <p:txBody>
-          <a:bodyPr/>
-          <a:lstStyle/>
-          <a:p>
-            <a:endParaRPr lang="en-US"/>
-          </a:p>
-        </p:txBody>
       </p:sp>
       <p:sp>
         <p:nvSpPr>
@@ -4224,7 +4238,7 @@
           <a:bodyPr wrap="square" rtlCol="0" anchor="ctr"/>
           <a:lstStyle/>
           <a:p>
-            <a:pPr marL="0" indent="0" algn="ctr">
+            <a:pPr algn="ctr" indent="0" marL="0">
               <a:buNone/>
             </a:pPr>
             <a:r>
@@ -4268,13 +4282,6 @@
             <a:prstDash val="solid"/>
           </a:ln>
         </p:spPr>
-        <p:txBody>
-          <a:bodyPr/>
-          <a:lstStyle/>
-          <a:p>
-            <a:endParaRPr lang="en-US"/>
-          </a:p>
-        </p:txBody>
       </p:sp>
       <p:sp>
         <p:nvSpPr>
@@ -4300,13 +4307,6 @@
             <a:prstDash val="solid"/>
           </a:ln>
         </p:spPr>
-        <p:txBody>
-          <a:bodyPr/>
-          <a:lstStyle/>
-          <a:p>
-            <a:endParaRPr lang="en-US"/>
-          </a:p>
-        </p:txBody>
       </p:sp>
       <p:sp>
         <p:nvSpPr>
@@ -4329,7 +4329,7 @@
           <a:bodyPr wrap="square" rtlCol="0" anchor="ctr"/>
           <a:lstStyle/>
           <a:p>
-            <a:pPr marL="0" indent="0" algn="ctr">
+            <a:pPr algn="ctr" indent="0" marL="0">
               <a:buNone/>
             </a:pPr>
             <a:r>
@@ -4368,7 +4368,7 @@
           <a:bodyPr wrap="square" rtlCol="0" anchor="ctr"/>
           <a:lstStyle/>
           <a:p>
-            <a:pPr marL="0" indent="0">
+            <a:pPr indent="0" marL="0">
               <a:buNone/>
             </a:pPr>
             <a:r>
@@ -4412,13 +4412,6 @@
             <a:prstDash val="solid"/>
           </a:ln>
         </p:spPr>
-        <p:txBody>
-          <a:bodyPr/>
-          <a:lstStyle/>
-          <a:p>
-            <a:endParaRPr lang="en-US"/>
-          </a:p>
-        </p:txBody>
       </p:sp>
       <p:sp>
         <p:nvSpPr>
@@ -4441,7 +4434,7 @@
           <a:bodyPr wrap="square" rtlCol="0" anchor="ctr"/>
           <a:lstStyle/>
           <a:p>
-            <a:pPr marL="0" indent="0" algn="ctr">
+            <a:pPr algn="ctr" indent="0" marL="0">
               <a:buNone/>
             </a:pPr>
             <a:r>
@@ -4485,13 +4478,6 @@
             <a:prstDash val="solid"/>
           </a:ln>
         </p:spPr>
-        <p:txBody>
-          <a:bodyPr/>
-          <a:lstStyle/>
-          <a:p>
-            <a:endParaRPr lang="en-US"/>
-          </a:p>
-        </p:txBody>
       </p:sp>
       <p:sp>
         <p:nvSpPr>
@@ -4517,13 +4503,6 @@
             <a:prstDash val="solid"/>
           </a:ln>
         </p:spPr>
-        <p:txBody>
-          <a:bodyPr/>
-          <a:lstStyle/>
-          <a:p>
-            <a:endParaRPr lang="en-US"/>
-          </a:p>
-        </p:txBody>
       </p:sp>
       <p:sp>
         <p:nvSpPr>
@@ -4546,7 +4525,7 @@
           <a:bodyPr wrap="square" rtlCol="0" anchor="ctr"/>
           <a:lstStyle/>
           <a:p>
-            <a:pPr marL="0" indent="0" algn="ctr">
+            <a:pPr algn="ctr" indent="0" marL="0">
               <a:buNone/>
             </a:pPr>
             <a:r>
@@ -4585,7 +4564,7 @@
           <a:bodyPr wrap="square" rtlCol="0" anchor="ctr"/>
           <a:lstStyle/>
           <a:p>
-            <a:pPr marL="0" indent="0">
+            <a:pPr indent="0" marL="0">
               <a:buNone/>
             </a:pPr>
             <a:r>
@@ -4629,13 +4608,6 @@
             <a:prstDash val="solid"/>
           </a:ln>
         </p:spPr>
-        <p:txBody>
-          <a:bodyPr/>
-          <a:lstStyle/>
-          <a:p>
-            <a:endParaRPr lang="en-US"/>
-          </a:p>
-        </p:txBody>
       </p:sp>
       <p:sp>
         <p:nvSpPr>
@@ -4658,7 +4630,7 @@
           <a:bodyPr wrap="square" rtlCol="0" anchor="ctr"/>
           <a:lstStyle/>
           <a:p>
-            <a:pPr marL="0" indent="0" algn="ctr">
+            <a:pPr algn="ctr" indent="0" marL="0">
               <a:buNone/>
             </a:pPr>
             <a:r>
@@ -4702,13 +4674,6 @@
             <a:prstDash val="solid"/>
           </a:ln>
         </p:spPr>
-        <p:txBody>
-          <a:bodyPr/>
-          <a:lstStyle/>
-          <a:p>
-            <a:endParaRPr lang="en-US"/>
-          </a:p>
-        </p:txBody>
       </p:sp>
       <p:sp>
         <p:nvSpPr>
@@ -4734,13 +4699,6 @@
             <a:prstDash val="solid"/>
           </a:ln>
         </p:spPr>
-        <p:txBody>
-          <a:bodyPr/>
-          <a:lstStyle/>
-          <a:p>
-            <a:endParaRPr lang="en-US"/>
-          </a:p>
-        </p:txBody>
       </p:sp>
       <p:sp>
         <p:nvSpPr>
@@ -4763,7 +4721,7 @@
           <a:bodyPr wrap="square" rtlCol="0" anchor="ctr"/>
           <a:lstStyle/>
           <a:p>
-            <a:pPr marL="0" indent="0" algn="ctr">
+            <a:pPr algn="ctr" indent="0" marL="0">
               <a:buNone/>
             </a:pPr>
             <a:r>
@@ -4802,7 +4760,7 @@
           <a:bodyPr wrap="square" rtlCol="0" anchor="ctr"/>
           <a:lstStyle/>
           <a:p>
-            <a:pPr marL="0" indent="0">
+            <a:pPr indent="0" marL="0">
               <a:buNone/>
             </a:pPr>
             <a:r>
@@ -4846,13 +4804,6 @@
             <a:prstDash val="solid"/>
           </a:ln>
         </p:spPr>
-        <p:txBody>
-          <a:bodyPr/>
-          <a:lstStyle/>
-          <a:p>
-            <a:endParaRPr lang="en-US"/>
-          </a:p>
-        </p:txBody>
       </p:sp>
       <p:sp>
         <p:nvSpPr>
@@ -4875,7 +4826,7 @@
           <a:bodyPr wrap="square" rtlCol="0" anchor="ctr"/>
           <a:lstStyle/>
           <a:p>
-            <a:pPr marL="0" indent="0" algn="ctr">
+            <a:pPr algn="ctr" indent="0" marL="0">
               <a:buNone/>
             </a:pPr>
             <a:r>
@@ -4914,7 +4865,7 @@
           <a:bodyPr wrap="square" rtlCol="0" anchor="ctr"/>
           <a:lstStyle/>
           <a:p>
-            <a:pPr marL="0" indent="0" algn="ctr">
+            <a:pPr algn="ctr" indent="0" marL="0">
               <a:buNone/>
             </a:pPr>
             <a:r>
@@ -4948,7 +4899,6 @@
         <a:solidFill>
           <a:srgbClr val="1A3A5C"/>
         </a:solidFill>
-        <a:effectLst/>
       </p:bgPr>
     </p:bg>
     <p:spTree>
@@ -4991,13 +4941,6 @@
             <a:prstDash val="solid"/>
           </a:ln>
         </p:spPr>
-        <p:txBody>
-          <a:bodyPr/>
-          <a:lstStyle/>
-          <a:p>
-            <a:endParaRPr lang="en-US"/>
-          </a:p>
-        </p:txBody>
       </p:sp>
       <p:sp>
         <p:nvSpPr>
@@ -5020,11 +4963,11 @@
           <a:bodyPr wrap="square" rtlCol="0" anchor="ctr"/>
           <a:lstStyle/>
           <a:p>
-            <a:pPr marL="0" indent="0">
-              <a:buNone/>
-            </a:pPr>
-            <a:r>
-              <a:rPr lang="en-US" sz="850" b="1" kern="0" spc="300" dirty="0">
+            <a:pPr indent="0" marL="0">
+              <a:buNone/>
+            </a:pPr>
+            <a:r>
+              <a:rPr lang="en-US" sz="850" b="1" spc="300" kern="0" dirty="0">
                 <a:solidFill>
                   <a:srgbClr val="F0A500"/>
                 </a:solidFill>
@@ -5059,7 +5002,7 @@
           <a:bodyPr wrap="square" rtlCol="0" anchor="ctr"/>
           <a:lstStyle/>
           <a:p>
-            <a:pPr marL="0" indent="0">
+            <a:pPr indent="0" marL="0">
               <a:buNone/>
             </a:pPr>
             <a:r>
@@ -5098,7 +5041,7 @@
           <a:bodyPr wrap="square" rtlCol="0" anchor="ctr"/>
           <a:lstStyle/>
           <a:p>
-            <a:pPr marL="0" indent="0">
+            <a:pPr indent="0" marL="0">
               <a:buNone/>
             </a:pPr>
             <a:r>
@@ -5142,13 +5085,6 @@
             <a:prstDash val="solid"/>
           </a:ln>
         </p:spPr>
-        <p:txBody>
-          <a:bodyPr/>
-          <a:lstStyle/>
-          <a:p>
-            <a:endParaRPr lang="en-US"/>
-          </a:p>
-        </p:txBody>
       </p:sp>
       <p:sp>
         <p:nvSpPr>
@@ -5171,11 +5107,11 @@
           <a:bodyPr wrap="square" rtlCol="0" anchor="ctr"/>
           <a:lstStyle/>
           <a:p>
-            <a:pPr marL="0" indent="0">
-              <a:buNone/>
-            </a:pPr>
-            <a:r>
-              <a:rPr lang="en-US" sz="900" b="1" kern="0" spc="200" dirty="0">
+            <a:pPr indent="0" marL="0">
+              <a:buNone/>
+            </a:pPr>
+            <a:r>
+              <a:rPr lang="en-US" sz="900" b="1" spc="200" kern="0" dirty="0">
                 <a:solidFill>
                   <a:srgbClr val="F0A500"/>
                 </a:solidFill>
@@ -5210,7 +5146,7 @@
           <a:bodyPr wrap="square" rtlCol="0" anchor="ctr"/>
           <a:lstStyle/>
           <a:p>
-            <a:pPr marL="0" indent="0">
+            <a:pPr indent="0" marL="0">
               <a:buNone/>
             </a:pPr>
             <a:r>
@@ -5249,7 +5185,7 @@
           <a:bodyPr wrap="square" rtlCol="0" anchor="ctr"/>
           <a:lstStyle/>
           <a:p>
-            <a:pPr marL="0" indent="0">
+            <a:pPr indent="0" marL="0">
               <a:buNone/>
             </a:pPr>
             <a:r>
@@ -5288,7 +5224,7 @@
           <a:bodyPr wrap="square" rtlCol="0" anchor="ctr"/>
           <a:lstStyle/>
           <a:p>
-            <a:pPr marL="0" indent="0">
+            <a:pPr indent="0" marL="0">
               <a:buNone/>
             </a:pPr>
             <a:r>
@@ -5327,7 +5263,7 @@
           <a:bodyPr wrap="square" rtlCol="0" anchor="ctr"/>
           <a:lstStyle/>
           <a:p>
-            <a:pPr marL="0" indent="0">
+            <a:pPr indent="0" marL="0">
               <a:buNone/>
             </a:pPr>
             <a:r>
@@ -5366,7 +5302,7 @@
           <a:bodyPr wrap="square" rtlCol="0" anchor="ctr"/>
           <a:lstStyle/>
           <a:p>
-            <a:pPr marL="0" indent="0">
+            <a:pPr indent="0" marL="0">
               <a:buNone/>
             </a:pPr>
             <a:r>
@@ -5405,7 +5341,7 @@
           <a:bodyPr wrap="square" rtlCol="0" anchor="ctr"/>
           <a:lstStyle/>
           <a:p>
-            <a:pPr marL="0" indent="0">
+            <a:pPr indent="0" marL="0">
               <a:buNone/>
             </a:pPr>
             <a:r>
@@ -5444,7 +5380,7 @@
           <a:bodyPr wrap="square" rtlCol="0" anchor="ctr"/>
           <a:lstStyle/>
           <a:p>
-            <a:pPr marL="0" indent="0">
+            <a:pPr indent="0" marL="0">
               <a:buNone/>
             </a:pPr>
             <a:r>
@@ -5483,7 +5419,7 @@
           <a:bodyPr wrap="square" rtlCol="0" anchor="ctr"/>
           <a:lstStyle/>
           <a:p>
-            <a:pPr marL="0" indent="0">
+            <a:pPr indent="0" marL="0">
               <a:buNone/>
             </a:pPr>
             <a:r>
@@ -5527,13 +5463,6 @@
             <a:prstDash val="solid"/>
           </a:ln>
         </p:spPr>
-        <p:txBody>
-          <a:bodyPr/>
-          <a:lstStyle/>
-          <a:p>
-            <a:endParaRPr lang="en-US"/>
-          </a:p>
-        </p:txBody>
       </p:sp>
       <p:sp>
         <p:nvSpPr>
@@ -5556,11 +5485,11 @@
           <a:bodyPr wrap="square" rtlCol="0" anchor="ctr"/>
           <a:lstStyle/>
           <a:p>
-            <a:pPr marL="0" indent="0">
-              <a:buNone/>
-            </a:pPr>
-            <a:r>
-              <a:rPr lang="en-US" sz="900" b="1" kern="0" spc="200" dirty="0">
+            <a:pPr indent="0" marL="0">
+              <a:buNone/>
+            </a:pPr>
+            <a:r>
+              <a:rPr lang="en-US" sz="900" b="1" spc="200" kern="0" dirty="0">
                 <a:solidFill>
                   <a:srgbClr val="C8102E"/>
                 </a:solidFill>
@@ -5595,7 +5524,7 @@
           <a:bodyPr wrap="square" rtlCol="0" anchor="ctr"/>
           <a:lstStyle/>
           <a:p>
-            <a:pPr marL="0" indent="0">
+            <a:pPr indent="0" marL="0">
               <a:buNone/>
             </a:pPr>
             <a:r>
@@ -5621,7 +5550,7 @@
         </p:nvSpPr>
         <p:spPr>
           <a:xfrm>
-            <a:off x="6318504" y="2976723"/>
+            <a:off x="6318504" y="2871216"/>
             <a:ext cx="256032" cy="256032"/>
           </a:xfrm>
           <a:prstGeom prst="ellipse">
@@ -5637,13 +5566,6 @@
             <a:prstDash val="solid"/>
           </a:ln>
         </p:spPr>
-        <p:txBody>
-          <a:bodyPr/>
-          <a:lstStyle/>
-          <a:p>
-            <a:endParaRPr lang="en-US"/>
-          </a:p>
-        </p:txBody>
       </p:sp>
       <p:sp>
         <p:nvSpPr>
@@ -5666,7 +5588,7 @@
           <a:bodyPr wrap="square" rtlCol="0" anchor="ctr"/>
           <a:lstStyle/>
           <a:p>
-            <a:pPr marL="0" indent="0">
+            <a:pPr indent="0" marL="0">
               <a:buNone/>
             </a:pPr>
             <a:r>
@@ -5692,7 +5614,7 @@
         </p:nvSpPr>
         <p:spPr>
           <a:xfrm>
-            <a:off x="6318504" y="3635091"/>
+            <a:off x="6318504" y="3529584"/>
             <a:ext cx="256032" cy="256032"/>
           </a:xfrm>
           <a:prstGeom prst="ellipse">
@@ -5708,13 +5630,6 @@
             <a:prstDash val="solid"/>
           </a:ln>
         </p:spPr>
-        <p:txBody>
-          <a:bodyPr/>
-          <a:lstStyle/>
-          <a:p>
-            <a:endParaRPr lang="en-US"/>
-          </a:p>
-        </p:txBody>
       </p:sp>
       <p:sp>
         <p:nvSpPr>
@@ -5737,7 +5652,7 @@
           <a:bodyPr wrap="square" rtlCol="0" anchor="ctr"/>
           <a:lstStyle/>
           <a:p>
-            <a:pPr marL="0" indent="0">
+            <a:pPr indent="0" marL="0">
               <a:buNone/>
             </a:pPr>
             <a:r>
@@ -5763,7 +5678,7 @@
         </p:nvSpPr>
         <p:spPr>
           <a:xfrm>
-            <a:off x="6318504" y="4305182"/>
+            <a:off x="6318504" y="4187952"/>
             <a:ext cx="256032" cy="256032"/>
           </a:xfrm>
           <a:prstGeom prst="ellipse">
@@ -5779,13 +5694,6 @@
             <a:prstDash val="solid"/>
           </a:ln>
         </p:spPr>
-        <p:txBody>
-          <a:bodyPr/>
-          <a:lstStyle/>
-          <a:p>
-            <a:endParaRPr lang="en-US"/>
-          </a:p>
-        </p:txBody>
       </p:sp>
       <p:sp>
         <p:nvSpPr>
@@ -5808,7 +5716,7 @@
           <a:bodyPr wrap="square" rtlCol="0" anchor="ctr"/>
           <a:lstStyle/>
           <a:p>
-            <a:pPr marL="0" indent="0">
+            <a:pPr indent="0" marL="0">
               <a:buNone/>
             </a:pPr>
             <a:r>
@@ -5834,7 +5742,7 @@
         </p:nvSpPr>
         <p:spPr>
           <a:xfrm>
-            <a:off x="6318504" y="4951827"/>
+            <a:off x="6318504" y="4846320"/>
             <a:ext cx="256032" cy="256032"/>
           </a:xfrm>
           <a:prstGeom prst="ellipse">
@@ -5850,13 +5758,6 @@
             <a:prstDash val="solid"/>
           </a:ln>
         </p:spPr>
-        <p:txBody>
-          <a:bodyPr/>
-          <a:lstStyle/>
-          <a:p>
-            <a:endParaRPr lang="en-US"/>
-          </a:p>
-        </p:txBody>
       </p:sp>
       <p:sp>
         <p:nvSpPr>
@@ -5879,7 +5780,7 @@
           <a:bodyPr wrap="square" rtlCol="0" anchor="ctr"/>
           <a:lstStyle/>
           <a:p>
-            <a:pPr marL="0" indent="0">
+            <a:pPr indent="0" marL="0">
               <a:buNone/>
             </a:pPr>
             <a:r>
@@ -5918,7 +5819,7 @@
           <a:bodyPr wrap="square" rtlCol="0" anchor="ctr"/>
           <a:lstStyle/>
           <a:p>
-            <a:pPr marL="0" indent="0" algn="ctr">
+            <a:pPr algn="ctr" indent="0" marL="0">
               <a:buNone/>
             </a:pPr>
             <a:r>
@@ -5952,7 +5853,6 @@
         <a:solidFill>
           <a:srgbClr val="FFFFFF"/>
         </a:solidFill>
-        <a:effectLst/>
       </p:bgPr>
     </p:bg>
     <p:spTree>
@@ -5990,11 +5890,11 @@
           <a:bodyPr wrap="square" rtlCol="0" anchor="ctr"/>
           <a:lstStyle/>
           <a:p>
-            <a:pPr marL="0" indent="0">
-              <a:buNone/>
-            </a:pPr>
-            <a:r>
-              <a:rPr lang="en-US" sz="850" b="1" kern="0" spc="300" dirty="0">
+            <a:pPr indent="0" marL="0">
+              <a:buNone/>
+            </a:pPr>
+            <a:r>
+              <a:rPr lang="en-US" sz="850" b="1" spc="300" kern="0" dirty="0">
                 <a:solidFill>
                   <a:srgbClr val="0E7C86"/>
                 </a:solidFill>
@@ -6029,7 +5929,7 @@
           <a:bodyPr wrap="square" rtlCol="0" anchor="ctr"/>
           <a:lstStyle/>
           <a:p>
-            <a:pPr marL="0" indent="0">
+            <a:pPr indent="0" marL="0">
               <a:buNone/>
             </a:pPr>
             <a:r>
@@ -6073,13 +5973,6 @@
             <a:prstDash val="solid"/>
           </a:ln>
         </p:spPr>
-        <p:txBody>
-          <a:bodyPr/>
-          <a:lstStyle/>
-          <a:p>
-            <a:endParaRPr lang="en-US"/>
-          </a:p>
-        </p:txBody>
       </p:sp>
       <p:sp>
         <p:nvSpPr>
@@ -6102,7 +5995,7 @@
           <a:bodyPr wrap="square" rtlCol="0" anchor="ctr"/>
           <a:lstStyle/>
           <a:p>
-            <a:pPr marL="0" indent="0" algn="ctr">
+            <a:pPr algn="ctr" indent="0" marL="0">
               <a:buNone/>
             </a:pPr>
             <a:r>
@@ -6141,7 +6034,7 @@
           <a:bodyPr wrap="square" rtlCol="0" anchor="ctr"/>
           <a:lstStyle/>
           <a:p>
-            <a:pPr marL="0" indent="0">
+            <a:pPr indent="0" marL="0">
               <a:buNone/>
             </a:pPr>
             <a:r>
@@ -6185,13 +6078,6 @@
             <a:prstDash val="solid"/>
           </a:ln>
         </p:spPr>
-        <p:txBody>
-          <a:bodyPr/>
-          <a:lstStyle/>
-          <a:p>
-            <a:endParaRPr lang="en-US"/>
-          </a:p>
-        </p:txBody>
       </p:sp>
       <p:sp>
         <p:nvSpPr>
@@ -6219,13 +6105,6 @@
             <a:prstDash val="solid"/>
           </a:ln>
         </p:spPr>
-        <p:txBody>
-          <a:bodyPr/>
-          <a:lstStyle/>
-          <a:p>
-            <a:endParaRPr lang="en-US"/>
-          </a:p>
-        </p:txBody>
       </p:sp>
       <p:sp>
         <p:nvSpPr>
@@ -6248,7 +6127,7 @@
           <a:bodyPr wrap="square" rtlCol="0" anchor="ctr"/>
           <a:lstStyle/>
           <a:p>
-            <a:pPr marL="0" indent="0">
+            <a:pPr indent="0" marL="0">
               <a:buNone/>
             </a:pPr>
             <a:r>
@@ -6287,7 +6166,7 @@
           <a:bodyPr wrap="square" rtlCol="0" anchor="ctr"/>
           <a:lstStyle/>
           <a:p>
-            <a:pPr marL="0" indent="0">
+            <a:pPr indent="0" marL="0">
               <a:buNone/>
             </a:pPr>
             <a:r>
@@ -6331,13 +6210,6 @@
             <a:prstDash val="solid"/>
           </a:ln>
         </p:spPr>
-        <p:txBody>
-          <a:bodyPr/>
-          <a:lstStyle/>
-          <a:p>
-            <a:endParaRPr lang="en-US"/>
-          </a:p>
-        </p:txBody>
       </p:sp>
       <p:sp>
         <p:nvSpPr>
@@ -6360,7 +6232,7 @@
           <a:bodyPr wrap="square" rtlCol="0" anchor="ctr"/>
           <a:lstStyle/>
           <a:p>
-            <a:pPr marL="0" indent="0" algn="ctr">
+            <a:pPr algn="ctr" indent="0" marL="0">
               <a:buNone/>
             </a:pPr>
             <a:r>
@@ -6404,13 +6276,6 @@
             <a:prstDash val="solid"/>
           </a:ln>
         </p:spPr>
-        <p:txBody>
-          <a:bodyPr/>
-          <a:lstStyle/>
-          <a:p>
-            <a:endParaRPr lang="en-US"/>
-          </a:p>
-        </p:txBody>
       </p:sp>
       <p:sp>
         <p:nvSpPr>
@@ -6438,13 +6303,6 @@
             <a:prstDash val="solid"/>
           </a:ln>
         </p:spPr>
-        <p:txBody>
-          <a:bodyPr/>
-          <a:lstStyle/>
-          <a:p>
-            <a:endParaRPr lang="en-US"/>
-          </a:p>
-        </p:txBody>
       </p:sp>
       <p:sp>
         <p:nvSpPr>
@@ -6467,7 +6325,7 @@
           <a:bodyPr wrap="square" rtlCol="0" anchor="ctr"/>
           <a:lstStyle/>
           <a:p>
-            <a:pPr marL="0" indent="0">
+            <a:pPr indent="0" marL="0">
               <a:buNone/>
             </a:pPr>
             <a:r>
@@ -6506,7 +6364,7 @@
           <a:bodyPr wrap="square" rtlCol="0" anchor="ctr"/>
           <a:lstStyle/>
           <a:p>
-            <a:pPr marL="0" indent="0">
+            <a:pPr indent="0" marL="0">
               <a:buNone/>
             </a:pPr>
             <a:r>
@@ -6550,13 +6408,6 @@
             <a:prstDash val="solid"/>
           </a:ln>
         </p:spPr>
-        <p:txBody>
-          <a:bodyPr/>
-          <a:lstStyle/>
-          <a:p>
-            <a:endParaRPr lang="en-US"/>
-          </a:p>
-        </p:txBody>
       </p:sp>
       <p:sp>
         <p:nvSpPr>
@@ -6579,7 +6430,7 @@
           <a:bodyPr wrap="square" rtlCol="0" anchor="ctr"/>
           <a:lstStyle/>
           <a:p>
-            <a:pPr marL="0" indent="0" algn="ctr">
+            <a:pPr algn="ctr" indent="0" marL="0">
               <a:buNone/>
             </a:pPr>
             <a:r>
@@ -6623,13 +6474,6 @@
             <a:prstDash val="solid"/>
           </a:ln>
         </p:spPr>
-        <p:txBody>
-          <a:bodyPr/>
-          <a:lstStyle/>
-          <a:p>
-            <a:endParaRPr lang="en-US"/>
-          </a:p>
-        </p:txBody>
       </p:sp>
       <p:sp>
         <p:nvSpPr>
@@ -6657,13 +6501,6 @@
             <a:prstDash val="solid"/>
           </a:ln>
         </p:spPr>
-        <p:txBody>
-          <a:bodyPr/>
-          <a:lstStyle/>
-          <a:p>
-            <a:endParaRPr lang="en-US"/>
-          </a:p>
-        </p:txBody>
       </p:sp>
       <p:sp>
         <p:nvSpPr>
@@ -6686,7 +6523,7 @@
           <a:bodyPr wrap="square" rtlCol="0" anchor="ctr"/>
           <a:lstStyle/>
           <a:p>
-            <a:pPr marL="0" indent="0">
+            <a:pPr indent="0" marL="0">
               <a:buNone/>
             </a:pPr>
             <a:r>
@@ -6725,7 +6562,7 @@
           <a:bodyPr wrap="square" rtlCol="0" anchor="ctr"/>
           <a:lstStyle/>
           <a:p>
-            <a:pPr marL="0" indent="0">
+            <a:pPr indent="0" marL="0">
               <a:buNone/>
             </a:pPr>
             <a:r>
@@ -6769,13 +6606,6 @@
             <a:prstDash val="solid"/>
           </a:ln>
         </p:spPr>
-        <p:txBody>
-          <a:bodyPr/>
-          <a:lstStyle/>
-          <a:p>
-            <a:endParaRPr lang="en-US"/>
-          </a:p>
-        </p:txBody>
       </p:sp>
       <p:sp>
         <p:nvSpPr>
@@ -6798,7 +6628,7 @@
           <a:bodyPr wrap="square" rtlCol="0" anchor="ctr"/>
           <a:lstStyle/>
           <a:p>
-            <a:pPr marL="0" indent="0" algn="ctr">
+            <a:pPr algn="ctr" indent="0" marL="0">
               <a:buNone/>
             </a:pPr>
             <a:r>
@@ -6842,13 +6672,6 @@
             <a:prstDash val="solid"/>
           </a:ln>
         </p:spPr>
-        <p:txBody>
-          <a:bodyPr/>
-          <a:lstStyle/>
-          <a:p>
-            <a:endParaRPr lang="en-US"/>
-          </a:p>
-        </p:txBody>
       </p:sp>
       <p:sp>
         <p:nvSpPr>
@@ -6876,13 +6699,6 @@
             <a:prstDash val="solid"/>
           </a:ln>
         </p:spPr>
-        <p:txBody>
-          <a:bodyPr/>
-          <a:lstStyle/>
-          <a:p>
-            <a:endParaRPr lang="en-US"/>
-          </a:p>
-        </p:txBody>
       </p:sp>
       <p:sp>
         <p:nvSpPr>
@@ -6905,7 +6721,7 @@
           <a:bodyPr wrap="square" rtlCol="0" anchor="ctr"/>
           <a:lstStyle/>
           <a:p>
-            <a:pPr marL="0" indent="0">
+            <a:pPr indent="0" marL="0">
               <a:buNone/>
             </a:pPr>
             <a:r>
@@ -6944,7 +6760,7 @@
           <a:bodyPr wrap="square" rtlCol="0" anchor="ctr"/>
           <a:lstStyle/>
           <a:p>
-            <a:pPr marL="0" indent="0">
+            <a:pPr indent="0" marL="0">
               <a:buNone/>
             </a:pPr>
             <a:r>
@@ -6988,13 +6804,6 @@
             <a:prstDash val="solid"/>
           </a:ln>
         </p:spPr>
-        <p:txBody>
-          <a:bodyPr/>
-          <a:lstStyle/>
-          <a:p>
-            <a:endParaRPr lang="en-US"/>
-          </a:p>
-        </p:txBody>
       </p:sp>
       <p:sp>
         <p:nvSpPr>
@@ -7017,7 +6826,7 @@
           <a:bodyPr wrap="square" rtlCol="0" anchor="ctr"/>
           <a:lstStyle/>
           <a:p>
-            <a:pPr marL="0" indent="0" algn="ctr">
+            <a:pPr algn="ctr" indent="0" marL="0">
               <a:buNone/>
             </a:pPr>
             <a:r>
@@ -7056,7 +6865,7 @@
           <a:bodyPr wrap="square" rtlCol="0" anchor="ctr"/>
           <a:lstStyle/>
           <a:p>
-            <a:pPr marL="0" indent="0" algn="ctr">
+            <a:pPr algn="ctr" indent="0" marL="0">
               <a:buNone/>
             </a:pPr>
             <a:r>
@@ -7090,7 +6899,6 @@
         <a:solidFill>
           <a:srgbClr val="FFFFFF"/>
         </a:solidFill>
-        <a:effectLst/>
       </p:bgPr>
     </p:bg>
     <p:spTree>
@@ -7128,11 +6936,11 @@
           <a:bodyPr wrap="square" rtlCol="0" anchor="ctr"/>
           <a:lstStyle/>
           <a:p>
-            <a:pPr marL="0" indent="0">
-              <a:buNone/>
-            </a:pPr>
-            <a:r>
-              <a:rPr lang="en-US" sz="850" b="1" kern="0" spc="300" dirty="0">
+            <a:pPr indent="0" marL="0">
+              <a:buNone/>
+            </a:pPr>
+            <a:r>
+              <a:rPr lang="en-US" sz="850" b="1" spc="300" kern="0" dirty="0">
                 <a:solidFill>
                   <a:srgbClr val="0E7C86"/>
                 </a:solidFill>
@@ -7167,7 +6975,7 @@
           <a:bodyPr wrap="square" rtlCol="0" anchor="ctr"/>
           <a:lstStyle/>
           <a:p>
-            <a:pPr marL="0" indent="0">
+            <a:pPr indent="0" marL="0">
               <a:buNone/>
             </a:pPr>
             <a:r>
@@ -7206,7 +7014,7 @@
           <a:bodyPr wrap="square" rtlCol="0" anchor="ctr"/>
           <a:lstStyle/>
           <a:p>
-            <a:pPr marL="0" indent="0">
+            <a:pPr indent="0" marL="0">
               <a:buNone/>
             </a:pPr>
             <a:r>
@@ -7250,13 +7058,6 @@
             <a:prstDash val="solid"/>
           </a:ln>
         </p:spPr>
-        <p:txBody>
-          <a:bodyPr/>
-          <a:lstStyle/>
-          <a:p>
-            <a:endParaRPr lang="en-US"/>
-          </a:p>
-        </p:txBody>
       </p:sp>
       <p:sp>
         <p:nvSpPr>
@@ -7284,13 +7085,6 @@
             <a:prstDash val="solid"/>
           </a:ln>
         </p:spPr>
-        <p:txBody>
-          <a:bodyPr/>
-          <a:lstStyle/>
-          <a:p>
-            <a:endParaRPr lang="en-US"/>
-          </a:p>
-        </p:txBody>
       </p:sp>
       <p:sp>
         <p:nvSpPr>
@@ -7313,11 +7107,11 @@
           <a:bodyPr wrap="square" rtlCol="0" anchor="ctr"/>
           <a:lstStyle/>
           <a:p>
-            <a:pPr marL="0" indent="0">
-              <a:buNone/>
-            </a:pPr>
-            <a:r>
-              <a:rPr lang="en-US" sz="950" b="1" kern="0" spc="100" dirty="0">
+            <a:pPr indent="0" marL="0">
+              <a:buNone/>
+            </a:pPr>
+            <a:r>
+              <a:rPr lang="en-US" sz="950" b="1" spc="100" kern="0" dirty="0">
                 <a:solidFill>
                   <a:srgbClr val="FFFFFF"/>
                 </a:solidFill>
@@ -7355,13 +7149,6 @@
             <a:prstDash val="solid"/>
           </a:ln>
         </p:spPr>
-        <p:txBody>
-          <a:bodyPr/>
-          <a:lstStyle/>
-          <a:p>
-            <a:endParaRPr lang="en-US"/>
-          </a:p>
-        </p:txBody>
       </p:sp>
       <p:sp>
         <p:nvSpPr>
@@ -7384,7 +7171,7 @@
           <a:bodyPr wrap="square" rtlCol="0" anchor="ctr"/>
           <a:lstStyle/>
           <a:p>
-            <a:pPr marL="0" indent="0">
+            <a:pPr indent="0" marL="0">
               <a:buNone/>
             </a:pPr>
             <a:r>
@@ -7426,13 +7213,6 @@
             <a:prstDash val="solid"/>
           </a:ln>
         </p:spPr>
-        <p:txBody>
-          <a:bodyPr/>
-          <a:lstStyle/>
-          <a:p>
-            <a:endParaRPr lang="en-US"/>
-          </a:p>
-        </p:txBody>
       </p:sp>
       <p:sp>
         <p:nvSpPr>
@@ -7455,7 +7235,7 @@
           <a:bodyPr wrap="square" rtlCol="0" anchor="ctr"/>
           <a:lstStyle/>
           <a:p>
-            <a:pPr marL="0" indent="0">
+            <a:pPr indent="0" marL="0">
               <a:buNone/>
             </a:pPr>
             <a:r>
@@ -7499,13 +7279,6 @@
             <a:prstDash val="solid"/>
           </a:ln>
         </p:spPr>
-        <p:txBody>
-          <a:bodyPr/>
-          <a:lstStyle/>
-          <a:p>
-            <a:endParaRPr lang="en-US"/>
-          </a:p>
-        </p:txBody>
       </p:sp>
       <p:sp>
         <p:nvSpPr>
@@ -7533,13 +7306,6 @@
             <a:prstDash val="solid"/>
           </a:ln>
         </p:spPr>
-        <p:txBody>
-          <a:bodyPr/>
-          <a:lstStyle/>
-          <a:p>
-            <a:endParaRPr lang="en-US"/>
-          </a:p>
-        </p:txBody>
       </p:sp>
       <p:sp>
         <p:nvSpPr>
@@ -7562,11 +7328,11 @@
           <a:bodyPr wrap="square" rtlCol="0" anchor="ctr"/>
           <a:lstStyle/>
           <a:p>
-            <a:pPr marL="0" indent="0">
-              <a:buNone/>
-            </a:pPr>
-            <a:r>
-              <a:rPr lang="en-US" sz="950" b="1" kern="0" spc="100" dirty="0">
+            <a:pPr indent="0" marL="0">
+              <a:buNone/>
+            </a:pPr>
+            <a:r>
+              <a:rPr lang="en-US" sz="950" b="1" spc="100" kern="0" dirty="0">
                 <a:solidFill>
                   <a:srgbClr val="FFFFFF"/>
                 </a:solidFill>
@@ -7604,13 +7370,6 @@
             <a:prstDash val="solid"/>
           </a:ln>
         </p:spPr>
-        <p:txBody>
-          <a:bodyPr/>
-          <a:lstStyle/>
-          <a:p>
-            <a:endParaRPr lang="en-US"/>
-          </a:p>
-        </p:txBody>
       </p:sp>
       <p:sp>
         <p:nvSpPr>
@@ -7633,7 +7392,7 @@
           <a:bodyPr wrap="square" rtlCol="0" anchor="ctr"/>
           <a:lstStyle/>
           <a:p>
-            <a:pPr marL="0" indent="0">
+            <a:pPr indent="0" marL="0">
               <a:buNone/>
             </a:pPr>
             <a:r>
@@ -7675,13 +7434,6 @@
             <a:prstDash val="solid"/>
           </a:ln>
         </p:spPr>
-        <p:txBody>
-          <a:bodyPr/>
-          <a:lstStyle/>
-          <a:p>
-            <a:endParaRPr lang="en-US"/>
-          </a:p>
-        </p:txBody>
       </p:sp>
       <p:sp>
         <p:nvSpPr>
@@ -7704,7 +7456,7 @@
           <a:bodyPr wrap="square" rtlCol="0" anchor="ctr"/>
           <a:lstStyle/>
           <a:p>
-            <a:pPr marL="0" indent="0">
+            <a:pPr indent="0" marL="0">
               <a:buNone/>
             </a:pPr>
             <a:r>
@@ -7748,13 +7500,6 @@
             <a:prstDash val="solid"/>
           </a:ln>
         </p:spPr>
-        <p:txBody>
-          <a:bodyPr/>
-          <a:lstStyle/>
-          <a:p>
-            <a:endParaRPr lang="en-US"/>
-          </a:p>
-        </p:txBody>
       </p:sp>
       <p:sp>
         <p:nvSpPr>
@@ -7782,13 +7527,6 @@
             <a:prstDash val="solid"/>
           </a:ln>
         </p:spPr>
-        <p:txBody>
-          <a:bodyPr/>
-          <a:lstStyle/>
-          <a:p>
-            <a:endParaRPr lang="en-US"/>
-          </a:p>
-        </p:txBody>
       </p:sp>
       <p:sp>
         <p:nvSpPr>
@@ -7811,11 +7549,11 @@
           <a:bodyPr wrap="square" rtlCol="0" anchor="ctr"/>
           <a:lstStyle/>
           <a:p>
-            <a:pPr marL="0" indent="0">
-              <a:buNone/>
-            </a:pPr>
-            <a:r>
-              <a:rPr lang="en-US" sz="950" b="1" kern="0" spc="100" dirty="0">
+            <a:pPr indent="0" marL="0">
+              <a:buNone/>
+            </a:pPr>
+            <a:r>
+              <a:rPr lang="en-US" sz="950" b="1" spc="100" kern="0" dirty="0">
                 <a:solidFill>
                   <a:srgbClr val="FFFFFF"/>
                 </a:solidFill>
@@ -7853,13 +7591,6 @@
             <a:prstDash val="solid"/>
           </a:ln>
         </p:spPr>
-        <p:txBody>
-          <a:bodyPr/>
-          <a:lstStyle/>
-          <a:p>
-            <a:endParaRPr lang="en-US"/>
-          </a:p>
-        </p:txBody>
       </p:sp>
       <p:sp>
         <p:nvSpPr>
@@ -7882,7 +7613,7 @@
           <a:bodyPr wrap="square" rtlCol="0" anchor="ctr"/>
           <a:lstStyle/>
           <a:p>
-            <a:pPr marL="0" indent="0">
+            <a:pPr indent="0" marL="0">
               <a:buNone/>
             </a:pPr>
             <a:r>
@@ -7924,13 +7655,6 @@
             <a:prstDash val="solid"/>
           </a:ln>
         </p:spPr>
-        <p:txBody>
-          <a:bodyPr/>
-          <a:lstStyle/>
-          <a:p>
-            <a:endParaRPr lang="en-US"/>
-          </a:p>
-        </p:txBody>
       </p:sp>
       <p:sp>
         <p:nvSpPr>
@@ -7953,7 +7677,7 @@
           <a:bodyPr wrap="square" rtlCol="0" anchor="ctr"/>
           <a:lstStyle/>
           <a:p>
-            <a:pPr marL="0" indent="0">
+            <a:pPr indent="0" marL="0">
               <a:buNone/>
             </a:pPr>
             <a:r>
@@ -7992,7 +7716,7 @@
           <a:bodyPr wrap="square" rtlCol="0" anchor="ctr"/>
           <a:lstStyle/>
           <a:p>
-            <a:pPr marL="0" indent="0" algn="ctr">
+            <a:pPr algn="ctr" indent="0" marL="0">
               <a:buNone/>
             </a:pPr>
             <a:r>
@@ -8026,7 +7750,6 @@
         <a:solidFill>
           <a:srgbClr val="FFFFFF"/>
         </a:solidFill>
-        <a:effectLst/>
       </p:bgPr>
     </p:bg>
     <p:spTree>
@@ -8064,11 +7787,11 @@
           <a:bodyPr wrap="square" rtlCol="0" anchor="ctr"/>
           <a:lstStyle/>
           <a:p>
-            <a:pPr marL="0" indent="0">
-              <a:buNone/>
-            </a:pPr>
-            <a:r>
-              <a:rPr lang="en-US" sz="850" b="1" kern="0" spc="300" dirty="0">
+            <a:pPr indent="0" marL="0">
+              <a:buNone/>
+            </a:pPr>
+            <a:r>
+              <a:rPr lang="en-US" sz="850" b="1" spc="300" kern="0" dirty="0">
                 <a:solidFill>
                   <a:srgbClr val="0E7C86"/>
                 </a:solidFill>
@@ -8103,7 +7826,7 @@
           <a:bodyPr wrap="square" rtlCol="0" anchor="ctr"/>
           <a:lstStyle/>
           <a:p>
-            <a:pPr marL="0" indent="0">
+            <a:pPr indent="0" marL="0">
               <a:buNone/>
             </a:pPr>
             <a:r>
@@ -8142,7 +7865,7 @@
           <a:bodyPr wrap="square" rtlCol="0" anchor="ctr"/>
           <a:lstStyle/>
           <a:p>
-            <a:pPr marL="0" indent="0">
+            <a:pPr indent="0" marL="0">
               <a:buNone/>
             </a:pPr>
             <a:r>
@@ -8186,13 +7909,6 @@
             <a:prstDash val="solid"/>
           </a:ln>
         </p:spPr>
-        <p:txBody>
-          <a:bodyPr/>
-          <a:lstStyle/>
-          <a:p>
-            <a:endParaRPr lang="en-US"/>
-          </a:p>
-        </p:txBody>
       </p:sp>
       <p:sp>
         <p:nvSpPr>
@@ -8218,13 +7934,6 @@
             <a:prstDash val="solid"/>
           </a:ln>
         </p:spPr>
-        <p:txBody>
-          <a:bodyPr/>
-          <a:lstStyle/>
-          <a:p>
-            <a:endParaRPr lang="en-US"/>
-          </a:p>
-        </p:txBody>
       </p:sp>
       <p:sp>
         <p:nvSpPr>
@@ -8247,7 +7956,7 @@
           <a:bodyPr wrap="square" rtlCol="0" anchor="ctr"/>
           <a:lstStyle/>
           <a:p>
-            <a:pPr marL="0" indent="0">
+            <a:pPr indent="0" marL="0">
               <a:buNone/>
             </a:pPr>
             <a:r>
@@ -8286,7 +7995,7 @@
           <a:bodyPr wrap="square" rtlCol="0" anchor="ctr"/>
           <a:lstStyle/>
           <a:p>
-            <a:pPr marL="0" indent="0">
+            <a:pPr indent="0" marL="0">
               <a:buNone/>
             </a:pPr>
             <a:r>
@@ -8330,13 +8039,6 @@
             <a:prstDash val="solid"/>
           </a:ln>
         </p:spPr>
-        <p:txBody>
-          <a:bodyPr/>
-          <a:lstStyle/>
-          <a:p>
-            <a:endParaRPr lang="en-US"/>
-          </a:p>
-        </p:txBody>
       </p:sp>
       <p:sp>
         <p:nvSpPr>
@@ -8364,13 +8066,6 @@
             <a:prstDash val="solid"/>
           </a:ln>
         </p:spPr>
-        <p:txBody>
-          <a:bodyPr/>
-          <a:lstStyle/>
-          <a:p>
-            <a:endParaRPr lang="en-US"/>
-          </a:p>
-        </p:txBody>
       </p:sp>
       <p:sp>
         <p:nvSpPr>
@@ -8393,11 +8088,11 @@
           <a:bodyPr wrap="square" rtlCol="0" anchor="ctr"/>
           <a:lstStyle/>
           <a:p>
-            <a:pPr marL="0" indent="0" algn="ctr">
-              <a:buNone/>
-            </a:pPr>
-            <a:r>
-              <a:rPr lang="en-US" sz="800" b="1" kern="0" spc="100" dirty="0">
+            <a:pPr algn="ctr" indent="0" marL="0">
+              <a:buNone/>
+            </a:pPr>
+            <a:r>
+              <a:rPr lang="en-US" sz="800" b="1" spc="100" kern="0" dirty="0">
                 <a:solidFill>
                   <a:srgbClr val="FFFFFF"/>
                 </a:solidFill>
@@ -8432,7 +8127,7 @@
           <a:bodyPr wrap="square" rtlCol="0" anchor="ctr"/>
           <a:lstStyle/>
           <a:p>
-            <a:pPr marL="0" indent="0" algn="ctr">
+            <a:pPr algn="ctr" indent="0" marL="0">
               <a:buNone/>
             </a:pPr>
             <a:r>
@@ -8476,13 +8171,6 @@
             <a:prstDash val="solid"/>
           </a:ln>
         </p:spPr>
-        <p:txBody>
-          <a:bodyPr/>
-          <a:lstStyle/>
-          <a:p>
-            <a:endParaRPr lang="en-US"/>
-          </a:p>
-        </p:txBody>
       </p:sp>
       <p:sp>
         <p:nvSpPr>
@@ -8510,13 +8198,6 @@
             <a:prstDash val="solid"/>
           </a:ln>
         </p:spPr>
-        <p:txBody>
-          <a:bodyPr/>
-          <a:lstStyle/>
-          <a:p>
-            <a:endParaRPr lang="en-US"/>
-          </a:p>
-        </p:txBody>
       </p:sp>
       <p:sp>
         <p:nvSpPr>
@@ -8539,11 +8220,11 @@
           <a:bodyPr wrap="square" rtlCol="0" anchor="ctr"/>
           <a:lstStyle/>
           <a:p>
-            <a:pPr marL="0" indent="0" algn="ctr">
-              <a:buNone/>
-            </a:pPr>
-            <a:r>
-              <a:rPr lang="en-US" sz="800" b="1" kern="0" spc="100" dirty="0">
+            <a:pPr algn="ctr" indent="0" marL="0">
+              <a:buNone/>
+            </a:pPr>
+            <a:r>
+              <a:rPr lang="en-US" sz="800" b="1" spc="100" kern="0" dirty="0">
                 <a:solidFill>
                   <a:srgbClr val="FFFFFF"/>
                 </a:solidFill>
@@ -8578,7 +8259,7 @@
           <a:bodyPr wrap="square" rtlCol="0" anchor="ctr"/>
           <a:lstStyle/>
           <a:p>
-            <a:pPr marL="0" indent="0" algn="ctr">
+            <a:pPr algn="ctr" indent="0" marL="0">
               <a:buNone/>
             </a:pPr>
             <a:r>
@@ -8622,13 +8303,6 @@
             <a:prstDash val="solid"/>
           </a:ln>
         </p:spPr>
-        <p:txBody>
-          <a:bodyPr/>
-          <a:lstStyle/>
-          <a:p>
-            <a:endParaRPr lang="en-US"/>
-          </a:p>
-        </p:txBody>
       </p:sp>
       <p:sp>
         <p:nvSpPr>
@@ -8656,13 +8330,6 @@
             <a:prstDash val="solid"/>
           </a:ln>
         </p:spPr>
-        <p:txBody>
-          <a:bodyPr/>
-          <a:lstStyle/>
-          <a:p>
-            <a:endParaRPr lang="en-US"/>
-          </a:p>
-        </p:txBody>
       </p:sp>
       <p:sp>
         <p:nvSpPr>
@@ -8685,11 +8352,11 @@
           <a:bodyPr wrap="square" rtlCol="0" anchor="ctr"/>
           <a:lstStyle/>
           <a:p>
-            <a:pPr marL="0" indent="0" algn="ctr">
-              <a:buNone/>
-            </a:pPr>
-            <a:r>
-              <a:rPr lang="en-US" sz="800" b="1" kern="0" spc="100" dirty="0">
+            <a:pPr algn="ctr" indent="0" marL="0">
+              <a:buNone/>
+            </a:pPr>
+            <a:r>
+              <a:rPr lang="en-US" sz="800" b="1" spc="100" kern="0" dirty="0">
                 <a:solidFill>
                   <a:srgbClr val="FFFFFF"/>
                 </a:solidFill>
@@ -8724,7 +8391,7 @@
           <a:bodyPr wrap="square" rtlCol="0" anchor="ctr"/>
           <a:lstStyle/>
           <a:p>
-            <a:pPr marL="0" indent="0" algn="ctr">
+            <a:pPr algn="ctr" indent="0" marL="0">
               <a:buNone/>
             </a:pPr>
             <a:r>
@@ -8768,13 +8435,6 @@
             <a:prstDash val="solid"/>
           </a:ln>
         </p:spPr>
-        <p:txBody>
-          <a:bodyPr/>
-          <a:lstStyle/>
-          <a:p>
-            <a:endParaRPr lang="en-US"/>
-          </a:p>
-        </p:txBody>
       </p:sp>
       <p:sp>
         <p:nvSpPr>
@@ -8800,13 +8460,6 @@
             <a:prstDash val="solid"/>
           </a:ln>
         </p:spPr>
-        <p:txBody>
-          <a:bodyPr/>
-          <a:lstStyle/>
-          <a:p>
-            <a:endParaRPr lang="en-US"/>
-          </a:p>
-        </p:txBody>
       </p:sp>
       <p:sp>
         <p:nvSpPr>
@@ -8829,7 +8482,7 @@
           <a:bodyPr wrap="square" rtlCol="0" anchor="ctr"/>
           <a:lstStyle/>
           <a:p>
-            <a:pPr marL="0" indent="0">
+            <a:pPr indent="0" marL="0">
               <a:buNone/>
             </a:pPr>
             <a:r>
@@ -8868,7 +8521,7 @@
           <a:bodyPr wrap="square" rtlCol="0" anchor="ctr"/>
           <a:lstStyle/>
           <a:p>
-            <a:pPr marL="0" indent="0">
+            <a:pPr indent="0" marL="0">
               <a:buNone/>
             </a:pPr>
             <a:r>
@@ -8907,7 +8560,7 @@
           <a:bodyPr wrap="square" rtlCol="0" anchor="ctr"/>
           <a:lstStyle/>
           <a:p>
-            <a:pPr marL="0" indent="0" algn="ctr">
+            <a:pPr algn="ctr" indent="0" marL="0">
               <a:buNone/>
             </a:pPr>
             <a:r>
@@ -8941,7 +8594,6 @@
         <a:solidFill>
           <a:srgbClr val="1A3A5C"/>
         </a:solidFill>
-        <a:effectLst/>
       </p:bgPr>
     </p:bg>
     <p:spTree>
@@ -8984,13 +8636,6 @@
             <a:prstDash val="solid"/>
           </a:ln>
         </p:spPr>
-        <p:txBody>
-          <a:bodyPr/>
-          <a:lstStyle/>
-          <a:p>
-            <a:endParaRPr lang="en-US"/>
-          </a:p>
-        </p:txBody>
       </p:sp>
       <p:sp>
         <p:nvSpPr>
@@ -9013,11 +8658,11 @@
           <a:bodyPr wrap="square" rtlCol="0" anchor="ctr"/>
           <a:lstStyle/>
           <a:p>
-            <a:pPr marL="0" indent="0">
-              <a:buNone/>
-            </a:pPr>
-            <a:r>
-              <a:rPr lang="en-US" sz="850" b="1" kern="0" spc="300" dirty="0">
+            <a:pPr indent="0" marL="0">
+              <a:buNone/>
+            </a:pPr>
+            <a:r>
+              <a:rPr lang="en-US" sz="850" b="1" spc="300" kern="0" dirty="0">
                 <a:solidFill>
                   <a:srgbClr val="F0A500"/>
                 </a:solidFill>
@@ -9052,7 +8697,7 @@
           <a:bodyPr wrap="square" rtlCol="0" anchor="ctr"/>
           <a:lstStyle/>
           <a:p>
-            <a:pPr marL="0" indent="0">
+            <a:pPr indent="0" marL="0">
               <a:buNone/>
             </a:pPr>
             <a:r>
@@ -9094,13 +8739,6 @@
             <a:prstDash val="solid"/>
           </a:ln>
         </p:spPr>
-        <p:txBody>
-          <a:bodyPr/>
-          <a:lstStyle/>
-          <a:p>
-            <a:endParaRPr lang="en-US"/>
-          </a:p>
-        </p:txBody>
       </p:sp>
       <p:sp>
         <p:nvSpPr>
@@ -9128,13 +8766,6 @@
             <a:prstDash val="solid"/>
           </a:ln>
         </p:spPr>
-        <p:txBody>
-          <a:bodyPr/>
-          <a:lstStyle/>
-          <a:p>
-            <a:endParaRPr lang="en-US"/>
-          </a:p>
-        </p:txBody>
       </p:sp>
       <p:sp>
         <p:nvSpPr>
@@ -9157,11 +8788,11 @@
           <a:bodyPr wrap="square" rtlCol="0" anchor="ctr"/>
           <a:lstStyle/>
           <a:p>
-            <a:pPr marL="0" indent="0">
-              <a:buNone/>
-            </a:pPr>
-            <a:r>
-              <a:rPr lang="en-US" sz="850" b="1" kern="0" spc="200" dirty="0">
+            <a:pPr indent="0" marL="0">
+              <a:buNone/>
+            </a:pPr>
+            <a:r>
+              <a:rPr lang="en-US" sz="850" b="1" spc="200" kern="0" dirty="0">
                 <a:solidFill>
                   <a:srgbClr val="F0A500"/>
                 </a:solidFill>
@@ -9196,7 +8827,7 @@
           <a:bodyPr wrap="square" rtlCol="0" anchor="ctr"/>
           <a:lstStyle/>
           <a:p>
-            <a:pPr marL="0" indent="0">
+            <a:pPr indent="0" marL="0">
               <a:buNone/>
             </a:pPr>
             <a:r>
@@ -9235,7 +8866,7 @@
           <a:bodyPr wrap="square" rtlCol="0" anchor="ctr"/>
           <a:lstStyle/>
           <a:p>
-            <a:pPr marL="0" indent="0">
+            <a:pPr indent="0" marL="0">
               <a:buNone/>
             </a:pPr>
             <a:r>
@@ -9274,7 +8905,7 @@
           <a:bodyPr wrap="square" rtlCol="0" anchor="ctr"/>
           <a:lstStyle/>
           <a:p>
-            <a:pPr marL="0" indent="0">
+            <a:pPr indent="0" marL="0">
               <a:buNone/>
             </a:pPr>
             <a:r>
@@ -9313,7 +8944,7 @@
           <a:bodyPr wrap="square" rtlCol="0" anchor="ctr"/>
           <a:lstStyle/>
           <a:p>
-            <a:pPr marL="0" indent="0">
+            <a:pPr indent="0" marL="0">
               <a:buNone/>
             </a:pPr>
             <a:r>
@@ -9352,7 +8983,7 @@
           <a:bodyPr wrap="square" rtlCol="0" anchor="ctr"/>
           <a:lstStyle/>
           <a:p>
-            <a:pPr marL="0" indent="0">
+            <a:pPr indent="0" marL="0">
               <a:buNone/>
             </a:pPr>
             <a:r>
@@ -9391,7 +9022,7 @@
           <a:bodyPr wrap="square" rtlCol="0" anchor="ctr"/>
           <a:lstStyle/>
           <a:p>
-            <a:pPr marL="0" indent="0">
+            <a:pPr indent="0" marL="0">
               <a:buNone/>
             </a:pPr>
             <a:r>
@@ -9430,7 +9061,7 @@
           <a:bodyPr wrap="square" rtlCol="0" anchor="ctr"/>
           <a:lstStyle/>
           <a:p>
-            <a:pPr marL="0" indent="0">
+            <a:pPr indent="0" marL="0">
               <a:buNone/>
             </a:pPr>
             <a:r>
@@ -9469,7 +9100,7 @@
           <a:bodyPr wrap="square" rtlCol="0" anchor="ctr"/>
           <a:lstStyle/>
           <a:p>
-            <a:pPr marL="0" indent="0">
+            <a:pPr indent="0" marL="0">
               <a:buNone/>
             </a:pPr>
             <a:r>
@@ -9513,13 +9144,6 @@
             <a:prstDash val="solid"/>
           </a:ln>
         </p:spPr>
-        <p:txBody>
-          <a:bodyPr/>
-          <a:lstStyle/>
-          <a:p>
-            <a:endParaRPr lang="en-US"/>
-          </a:p>
-        </p:txBody>
       </p:sp>
       <p:sp>
         <p:nvSpPr>
@@ -9542,11 +9166,11 @@
           <a:bodyPr wrap="square" rtlCol="0" anchor="ctr"/>
           <a:lstStyle/>
           <a:p>
-            <a:pPr marL="0" indent="0">
-              <a:buNone/>
-            </a:pPr>
-            <a:r>
-              <a:rPr lang="en-US" sz="850" b="1" kern="0" spc="200" dirty="0">
+            <a:pPr indent="0" marL="0">
+              <a:buNone/>
+            </a:pPr>
+            <a:r>
+              <a:rPr lang="en-US" sz="850" b="1" spc="200" kern="0" dirty="0">
                 <a:solidFill>
                   <a:srgbClr val="C8102E"/>
                 </a:solidFill>
@@ -9562,15 +9186,13 @@
       </p:sp>
       <p:sp>
         <p:nvSpPr>
-          <p:cNvPr id="18" name="Shape 16">
-            <a:hlinkClick r:id="rId4"/>
-          </p:cNvPr>
-          <p:cNvSpPr/>
-          <p:nvPr/>
-        </p:nvSpPr>
-        <p:spPr>
-          <a:xfrm>
-            <a:off x="8549640" y="2130552"/>
+          <p:cNvPr id="18" name="Shape 16"/>
+          <p:cNvSpPr/>
+          <p:nvPr/>
+        </p:nvSpPr>
+        <p:spPr>
+          <a:xfrm>
+            <a:off x="8641080" y="2148840"/>
             <a:ext cx="1371600" cy="1371600"/>
           </a:xfrm>
           <a:prstGeom prst="ellipse">
@@ -9588,11 +9210,43 @@
             <a:prstDash val="solid"/>
           </a:ln>
         </p:spPr>
-        <p:txBody>
-          <a:bodyPr/>
-          <a:lstStyle/>
-          <a:p>
-            <a:endParaRPr lang="en-US"/>
+      </p:sp>
+      <p:sp>
+        <p:nvSpPr>
+          <p:cNvPr id="19" name="Text 17"/>
+          <p:cNvSpPr/>
+          <p:nvPr/>
+        </p:nvSpPr>
+        <p:spPr>
+          <a:xfrm>
+            <a:off x="8641080" y="2148840"/>
+            <a:ext cx="1371600" cy="1371600"/>
+          </a:xfrm>
+          <a:prstGeom prst="rect">
+            <a:avLst/>
+          </a:prstGeom>
+          <a:noFill/>
+          <a:ln/>
+        </p:spPr>
+        <p:txBody>
+          <a:bodyPr wrap="square" rtlCol="0" anchor="ctr"/>
+          <a:lstStyle/>
+          <a:p>
+            <a:pPr algn="ctr" indent="0" marL="0">
+              <a:buNone/>
+            </a:pPr>
+            <a:r>
+              <a:rPr lang="en-US" sz="3200" dirty="0">
+                <a:solidFill>
+                  <a:srgbClr val="FFFFFF"/>
+                </a:solidFill>
+                <a:latin typeface="Calibri" pitchFamily="34" charset="0"/>
+                <a:ea typeface="Calibri" pitchFamily="34" charset="-122"/>
+                <a:cs typeface="Calibri" pitchFamily="34" charset="-120"/>
+              </a:rPr>
+              <a:t>▶</a:t>
+            </a:r>
+            <a:endParaRPr lang="en-US" sz="3200" dirty="0"/>
           </a:p>
         </p:txBody>
       </p:sp>
@@ -9617,7 +9271,7 @@
           <a:bodyPr wrap="square" rtlCol="0" anchor="ctr"/>
           <a:lstStyle/>
           <a:p>
-            <a:pPr marL="0" indent="0" algn="ctr">
+            <a:pPr algn="ctr" indent="0" marL="0">
               <a:buNone/>
             </a:pPr>
             <a:r>
@@ -9634,7 +9288,7 @@
             <a:endParaRPr lang="en-US" sz="1100" dirty="0"/>
           </a:p>
           <a:p>
-            <a:pPr marL="0" indent="0" algn="ctr">
+            <a:pPr algn="ctr" indent="0" marL="0">
               <a:buNone/>
             </a:pPr>
             <a:r>
@@ -9646,7 +9300,7 @@
                 <a:ea typeface="Calibri" pitchFamily="34" charset="-122"/>
                 <a:cs typeface="Calibri" pitchFamily="34" charset="-120"/>
               </a:rPr>
-              <a:t>Pre-load and timestamp from 0:41 to 2:25 before class</a:t>
+              <a:t>Pre-load and timestamp before class</a:t>
             </a:r>
             <a:endParaRPr lang="en-US" sz="1100" dirty="0"/>
           </a:p>
@@ -9673,7 +9327,7 @@
           <a:bodyPr wrap="square" rtlCol="0" anchor="ctr"/>
           <a:lstStyle/>
           <a:p>
-            <a:pPr marL="0" indent="0">
+            <a:pPr indent="0" marL="0">
               <a:buNone/>
             </a:pPr>
             <a:r>
@@ -9712,7 +9366,7 @@
           <a:bodyPr wrap="square" rtlCol="0" anchor="ctr"/>
           <a:lstStyle/>
           <a:p>
-            <a:pPr marL="0" indent="0" algn="ctr">
+            <a:pPr algn="ctr" indent="0" marL="0">
               <a:buNone/>
             </a:pPr>
             <a:r>
@@ -9730,179 +9384,11 @@
           </a:p>
         </p:txBody>
       </p:sp>
-      <p:pic>
-        <p:nvPicPr>
-          <p:cNvPr id="24" name="Online Media 23" descr="How do genetic changes contribute to acute lymphoblastic leukemia (ALL) development?">
-            <a:hlinkClick r:id="" action="ppaction://media"/>
-            <a:extLst>
-              <a:ext uri="{FF2B5EF4-FFF2-40B4-BE49-F238E27FC236}">
-                <a16:creationId xmlns:a16="http://schemas.microsoft.com/office/drawing/2014/main" id="{2618B527-1823-66A1-1254-2CC515CFE926}"/>
-              </a:ext>
-            </a:extLst>
-          </p:cNvPr>
-          <p:cNvPicPr>
-            <a:picLocks noRot="1" noChangeAspect="1"/>
-          </p:cNvPicPr>
-          <p:nvPr>
-            <a:videoFile r:link="rId1"/>
-          </p:nvPr>
-        </p:nvPicPr>
-        <p:blipFill>
-          <a:blip r:embed="rId5"/>
-          <a:stretch>
-            <a:fillRect/>
-          </a:stretch>
-        </p:blipFill>
-        <p:spPr>
-          <a:xfrm>
-            <a:off x="7965440" y="2067052"/>
-            <a:ext cx="2540000" cy="1435100"/>
-          </a:xfrm>
-          <a:prstGeom prst="rect">
-            <a:avLst/>
-          </a:prstGeom>
-        </p:spPr>
-      </p:pic>
     </p:spTree>
   </p:cSld>
   <p:clrMapOvr>
     <a:masterClrMapping/>
   </p:clrMapOvr>
-  <p:timing>
-    <p:tnLst>
-      <p:par>
-        <p:cTn id="1" dur="indefinite" restart="never" nodeType="tmRoot">
-          <p:childTnLst>
-            <p:seq concurrent="1" nextAc="seek">
-              <p:cTn id="2" dur="indefinite" nodeType="mainSeq">
-                <p:childTnLst>
-                  <p:par>
-                    <p:cTn id="3" fill="hold">
-                      <p:stCondLst>
-                        <p:cond delay="indefinite"/>
-                      </p:stCondLst>
-                      <p:childTnLst>
-                        <p:par>
-                          <p:cTn id="4" fill="hold">
-                            <p:stCondLst>
-                              <p:cond delay="0"/>
-                            </p:stCondLst>
-                            <p:childTnLst>
-                              <p:par>
-                                <p:cTn id="5" presetID="1" presetClass="mediacall" presetSubtype="0" fill="hold" nodeType="clickEffect">
-                                  <p:stCondLst>
-                                    <p:cond delay="0"/>
-                                  </p:stCondLst>
-                                  <p:childTnLst>
-                                    <p:cmd type="call" cmd="playFrom(0.0)">
-                                      <p:cBhvr>
-                                        <p:cTn id="6" dur="1" fill="hold"/>
-                                        <p:tgtEl>
-                                          <p:spTgt spid="24"/>
-                                        </p:tgtEl>
-                                      </p:cBhvr>
-                                    </p:cmd>
-                                  </p:childTnLst>
-                                </p:cTn>
-                              </p:par>
-                            </p:childTnLst>
-                          </p:cTn>
-                        </p:par>
-                      </p:childTnLst>
-                    </p:cTn>
-                  </p:par>
-                </p:childTnLst>
-              </p:cTn>
-              <p:prevCondLst>
-                <p:cond evt="onPrev" delay="0">
-                  <p:tgtEl>
-                    <p:sldTgt/>
-                  </p:tgtEl>
-                </p:cond>
-              </p:prevCondLst>
-              <p:nextCondLst>
-                <p:cond evt="onNext" delay="0">
-                  <p:tgtEl>
-                    <p:sldTgt/>
-                  </p:tgtEl>
-                </p:cond>
-              </p:nextCondLst>
-            </p:seq>
-            <p:video>
-              <p:cMediaNode vol="80000">
-                <p:cTn id="7" fill="hold" display="0">
-                  <p:stCondLst>
-                    <p:cond delay="indefinite"/>
-                  </p:stCondLst>
-                </p:cTn>
-                <p:tgtEl>
-                  <p:spTgt spid="24"/>
-                </p:tgtEl>
-              </p:cMediaNode>
-            </p:video>
-            <p:seq concurrent="1" nextAc="seek">
-              <p:cTn id="8" restart="whenNotActive" fill="hold" evtFilter="cancelBubble" nodeType="interactiveSeq">
-                <p:stCondLst>
-                  <p:cond evt="onClick" delay="0">
-                    <p:tgtEl>
-                      <p:spTgt spid="24"/>
-                    </p:tgtEl>
-                  </p:cond>
-                </p:stCondLst>
-                <p:endSync evt="end" delay="0">
-                  <p:rtn val="all"/>
-                </p:endSync>
-                <p:childTnLst>
-                  <p:par>
-                    <p:cTn id="9" fill="hold">
-                      <p:stCondLst>
-                        <p:cond delay="0"/>
-                      </p:stCondLst>
-                      <p:childTnLst>
-                        <p:par>
-                          <p:cTn id="10" fill="hold">
-                            <p:stCondLst>
-                              <p:cond delay="0"/>
-                            </p:stCondLst>
-                            <p:childTnLst>
-                              <p:par>
-                                <p:cTn id="11" presetID="2" presetClass="mediacall" presetSubtype="0" fill="hold" nodeType="clickEffect">
-                                  <p:stCondLst>
-                                    <p:cond delay="0"/>
-                                  </p:stCondLst>
-                                  <p:childTnLst>
-                                    <p:cmd type="call" cmd="togglePause">
-                                      <p:cBhvr>
-                                        <p:cTn id="12" dur="1" fill="hold"/>
-                                        <p:tgtEl>
-                                          <p:spTgt spid="24"/>
-                                        </p:tgtEl>
-                                      </p:cBhvr>
-                                    </p:cmd>
-                                  </p:childTnLst>
-                                </p:cTn>
-                              </p:par>
-                            </p:childTnLst>
-                          </p:cTn>
-                        </p:par>
-                      </p:childTnLst>
-                    </p:cTn>
-                  </p:par>
-                </p:childTnLst>
-              </p:cTn>
-              <p:nextCondLst>
-                <p:cond evt="onClick" delay="0">
-                  <p:tgtEl>
-                    <p:spTgt spid="24"/>
-                  </p:tgtEl>
-                </p:cond>
-              </p:nextCondLst>
-            </p:seq>
-          </p:childTnLst>
-        </p:cTn>
-      </p:par>
-    </p:tnLst>
-  </p:timing>
 </p:sld>
 </file>
 
@@ -9914,7 +9400,6 @@
         <a:solidFill>
           <a:srgbClr val="FFFFFF"/>
         </a:solidFill>
-        <a:effectLst/>
       </p:bgPr>
     </p:bg>
     <p:spTree>
@@ -9952,11 +9437,11 @@
           <a:bodyPr wrap="square" rtlCol="0" anchor="ctr"/>
           <a:lstStyle/>
           <a:p>
-            <a:pPr marL="0" indent="0">
-              <a:buNone/>
-            </a:pPr>
-            <a:r>
-              <a:rPr lang="en-US" sz="850" b="1" kern="0" spc="300" dirty="0">
+            <a:pPr indent="0" marL="0">
+              <a:buNone/>
+            </a:pPr>
+            <a:r>
+              <a:rPr lang="en-US" sz="850" b="1" spc="300" kern="0" dirty="0">
                 <a:solidFill>
                   <a:srgbClr val="0E7C86"/>
                 </a:solidFill>
@@ -9991,7 +9476,7 @@
           <a:bodyPr wrap="square" rtlCol="0" anchor="ctr"/>
           <a:lstStyle/>
           <a:p>
-            <a:pPr marL="0" indent="0">
+            <a:pPr indent="0" marL="0">
               <a:buNone/>
             </a:pPr>
             <a:r>
@@ -10030,7 +9515,7 @@
           <a:bodyPr wrap="square" rtlCol="0" anchor="ctr"/>
           <a:lstStyle/>
           <a:p>
-            <a:pPr marL="0" indent="0">
+            <a:pPr indent="0" marL="0">
               <a:buNone/>
             </a:pPr>
             <a:r>
@@ -10074,13 +9559,6 @@
             <a:prstDash val="solid"/>
           </a:ln>
         </p:spPr>
-        <p:txBody>
-          <a:bodyPr/>
-          <a:lstStyle/>
-          <a:p>
-            <a:endParaRPr lang="en-US"/>
-          </a:p>
-        </p:txBody>
       </p:sp>
       <p:sp>
         <p:nvSpPr>
@@ -10108,13 +9586,6 @@
             <a:prstDash val="solid"/>
           </a:ln>
         </p:spPr>
-        <p:txBody>
-          <a:bodyPr/>
-          <a:lstStyle/>
-          <a:p>
-            <a:endParaRPr lang="en-US"/>
-          </a:p>
-        </p:txBody>
       </p:sp>
       <p:sp>
         <p:nvSpPr>
@@ -10140,13 +9611,6 @@
             <a:prstDash val="solid"/>
           </a:ln>
         </p:spPr>
-        <p:txBody>
-          <a:bodyPr/>
-          <a:lstStyle/>
-          <a:p>
-            <a:endParaRPr lang="en-US"/>
-          </a:p>
-        </p:txBody>
       </p:sp>
       <p:sp>
         <p:nvSpPr>
@@ -10169,7 +9633,7 @@
           <a:bodyPr wrap="square" rtlCol="0" anchor="ctr"/>
           <a:lstStyle/>
           <a:p>
-            <a:pPr marL="0" indent="0" algn="ctr">
+            <a:pPr algn="ctr" indent="0" marL="0">
               <a:buNone/>
             </a:pPr>
             <a:r>
@@ -10208,7 +9672,7 @@
           <a:bodyPr wrap="square" rtlCol="0" anchor="ctr"/>
           <a:lstStyle/>
           <a:p>
-            <a:pPr marL="0" indent="0" algn="ctr">
+            <a:pPr algn="ctr" indent="0" marL="0">
               <a:buNone/>
             </a:pPr>
             <a:r>
@@ -10247,7 +9711,7 @@
           <a:bodyPr wrap="square" rtlCol="0" anchor="ctr"/>
           <a:lstStyle/>
           <a:p>
-            <a:pPr marL="0" indent="0" algn="ctr">
+            <a:pPr algn="ctr" indent="0" marL="0">
               <a:buNone/>
             </a:pPr>
             <a:r>
@@ -10286,7 +9750,7 @@
           <a:bodyPr wrap="square" rtlCol="0" anchor="ctr"/>
           <a:lstStyle/>
           <a:p>
-            <a:pPr marL="0" indent="0" algn="ctr">
+            <a:pPr algn="ctr" indent="0" marL="0">
               <a:buNone/>
             </a:pPr>
             <a:r>
@@ -10330,13 +9794,6 @@
             <a:prstDash val="solid"/>
           </a:ln>
         </p:spPr>
-        <p:txBody>
-          <a:bodyPr/>
-          <a:lstStyle/>
-          <a:p>
-            <a:endParaRPr lang="en-US"/>
-          </a:p>
-        </p:txBody>
       </p:sp>
       <p:sp>
         <p:nvSpPr>
@@ -10364,13 +9821,6 @@
             <a:prstDash val="solid"/>
           </a:ln>
         </p:spPr>
-        <p:txBody>
-          <a:bodyPr/>
-          <a:lstStyle/>
-          <a:p>
-            <a:endParaRPr lang="en-US"/>
-          </a:p>
-        </p:txBody>
       </p:sp>
       <p:sp>
         <p:nvSpPr>
@@ -10396,13 +9846,6 @@
             <a:prstDash val="solid"/>
           </a:ln>
         </p:spPr>
-        <p:txBody>
-          <a:bodyPr/>
-          <a:lstStyle/>
-          <a:p>
-            <a:endParaRPr lang="en-US"/>
-          </a:p>
-        </p:txBody>
       </p:sp>
       <p:sp>
         <p:nvSpPr>
@@ -10425,7 +9868,7 @@
           <a:bodyPr wrap="square" rtlCol="0" anchor="ctr"/>
           <a:lstStyle/>
           <a:p>
-            <a:pPr marL="0" indent="0" algn="ctr">
+            <a:pPr algn="ctr" indent="0" marL="0">
               <a:buNone/>
             </a:pPr>
             <a:r>
@@ -10464,7 +9907,7 @@
           <a:bodyPr wrap="square" rtlCol="0" anchor="ctr"/>
           <a:lstStyle/>
           <a:p>
-            <a:pPr marL="0" indent="0" algn="ctr">
+            <a:pPr algn="ctr" indent="0" marL="0">
               <a:buNone/>
             </a:pPr>
             <a:r>
@@ -10503,7 +9946,7 @@
           <a:bodyPr wrap="square" rtlCol="0" anchor="ctr"/>
           <a:lstStyle/>
           <a:p>
-            <a:pPr marL="0" indent="0" algn="ctr">
+            <a:pPr algn="ctr" indent="0" marL="0">
               <a:buNone/>
             </a:pPr>
             <a:r>
@@ -10542,7 +9985,7 @@
           <a:bodyPr wrap="square" rtlCol="0" anchor="ctr"/>
           <a:lstStyle/>
           <a:p>
-            <a:pPr marL="0" indent="0" algn="ctr">
+            <a:pPr algn="ctr" indent="0" marL="0">
               <a:buNone/>
             </a:pPr>
             <a:r>
@@ -10586,13 +10029,6 @@
             <a:prstDash val="solid"/>
           </a:ln>
         </p:spPr>
-        <p:txBody>
-          <a:bodyPr/>
-          <a:lstStyle/>
-          <a:p>
-            <a:endParaRPr lang="en-US"/>
-          </a:p>
-        </p:txBody>
       </p:sp>
       <p:sp>
         <p:nvSpPr>
@@ -10620,13 +10056,6 @@
             <a:prstDash val="solid"/>
           </a:ln>
         </p:spPr>
-        <p:txBody>
-          <a:bodyPr/>
-          <a:lstStyle/>
-          <a:p>
-            <a:endParaRPr lang="en-US"/>
-          </a:p>
-        </p:txBody>
       </p:sp>
       <p:sp>
         <p:nvSpPr>
@@ -10652,13 +10081,6 @@
             <a:prstDash val="solid"/>
           </a:ln>
         </p:spPr>
-        <p:txBody>
-          <a:bodyPr/>
-          <a:lstStyle/>
-          <a:p>
-            <a:endParaRPr lang="en-US"/>
-          </a:p>
-        </p:txBody>
       </p:sp>
       <p:sp>
         <p:nvSpPr>
@@ -10681,7 +10103,7 @@
           <a:bodyPr wrap="square" rtlCol="0" anchor="ctr"/>
           <a:lstStyle/>
           <a:p>
-            <a:pPr marL="0" indent="0" algn="ctr">
+            <a:pPr algn="ctr" indent="0" marL="0">
               <a:buNone/>
             </a:pPr>
             <a:r>
@@ -10720,7 +10142,7 @@
           <a:bodyPr wrap="square" rtlCol="0" anchor="ctr"/>
           <a:lstStyle/>
           <a:p>
-            <a:pPr marL="0" indent="0" algn="ctr">
+            <a:pPr algn="ctr" indent="0" marL="0">
               <a:buNone/>
             </a:pPr>
             <a:r>
@@ -10759,7 +10181,7 @@
           <a:bodyPr wrap="square" rtlCol="0" anchor="ctr"/>
           <a:lstStyle/>
           <a:p>
-            <a:pPr marL="0" indent="0" algn="ctr">
+            <a:pPr algn="ctr" indent="0" marL="0">
               <a:buNone/>
             </a:pPr>
             <a:r>
@@ -10798,7 +10220,7 @@
           <a:bodyPr wrap="square" rtlCol="0" anchor="ctr"/>
           <a:lstStyle/>
           <a:p>
-            <a:pPr marL="0" indent="0" algn="ctr">
+            <a:pPr algn="ctr" indent="0" marL="0">
               <a:buNone/>
             </a:pPr>
             <a:r>
@@ -10842,13 +10264,6 @@
             <a:prstDash val="solid"/>
           </a:ln>
         </p:spPr>
-        <p:txBody>
-          <a:bodyPr/>
-          <a:lstStyle/>
-          <a:p>
-            <a:endParaRPr lang="en-US"/>
-          </a:p>
-        </p:txBody>
       </p:sp>
       <p:sp>
         <p:nvSpPr>
@@ -10876,13 +10291,6 @@
             <a:prstDash val="solid"/>
           </a:ln>
         </p:spPr>
-        <p:txBody>
-          <a:bodyPr/>
-          <a:lstStyle/>
-          <a:p>
-            <a:endParaRPr lang="en-US"/>
-          </a:p>
-        </p:txBody>
       </p:sp>
       <p:sp>
         <p:nvSpPr>
@@ -10908,13 +10316,6 @@
             <a:prstDash val="solid"/>
           </a:ln>
         </p:spPr>
-        <p:txBody>
-          <a:bodyPr/>
-          <a:lstStyle/>
-          <a:p>
-            <a:endParaRPr lang="en-US"/>
-          </a:p>
-        </p:txBody>
       </p:sp>
       <p:sp>
         <p:nvSpPr>
@@ -10937,7 +10338,7 @@
           <a:bodyPr wrap="square" rtlCol="0" anchor="ctr"/>
           <a:lstStyle/>
           <a:p>
-            <a:pPr marL="0" indent="0" algn="ctr">
+            <a:pPr algn="ctr" indent="0" marL="0">
               <a:buNone/>
             </a:pPr>
             <a:r>
@@ -10976,7 +10377,7 @@
           <a:bodyPr wrap="square" rtlCol="0" anchor="ctr"/>
           <a:lstStyle/>
           <a:p>
-            <a:pPr marL="0" indent="0" algn="ctr">
+            <a:pPr algn="ctr" indent="0" marL="0">
               <a:buNone/>
             </a:pPr>
             <a:r>
@@ -11015,7 +10416,7 @@
           <a:bodyPr wrap="square" rtlCol="0" anchor="ctr"/>
           <a:lstStyle/>
           <a:p>
-            <a:pPr marL="0" indent="0" algn="ctr">
+            <a:pPr algn="ctr" indent="0" marL="0">
               <a:buNone/>
             </a:pPr>
             <a:r>
@@ -11059,13 +10460,6 @@
             <a:prstDash val="solid"/>
           </a:ln>
         </p:spPr>
-        <p:txBody>
-          <a:bodyPr/>
-          <a:lstStyle/>
-          <a:p>
-            <a:endParaRPr lang="en-US"/>
-          </a:p>
-        </p:txBody>
       </p:sp>
       <p:sp>
         <p:nvSpPr>
@@ -11091,13 +10485,6 @@
             <a:prstDash val="solid"/>
           </a:ln>
         </p:spPr>
-        <p:txBody>
-          <a:bodyPr/>
-          <a:lstStyle/>
-          <a:p>
-            <a:endParaRPr lang="en-US"/>
-          </a:p>
-        </p:txBody>
       </p:sp>
       <p:sp>
         <p:nvSpPr>
@@ -11120,7 +10507,7 @@
           <a:bodyPr wrap="square" rtlCol="0" anchor="ctr"/>
           <a:lstStyle/>
           <a:p>
-            <a:pPr marL="0" indent="0">
+            <a:pPr indent="0" marL="0">
               <a:buNone/>
             </a:pPr>
             <a:r>
@@ -11159,7 +10546,7 @@
           <a:bodyPr wrap="square" rtlCol="0" anchor="ctr"/>
           <a:lstStyle/>
           <a:p>
-            <a:pPr marL="0" indent="0">
+            <a:pPr indent="0" marL="0">
               <a:buNone/>
             </a:pPr>
             <a:r>
@@ -11198,7 +10585,7 @@
           <a:bodyPr wrap="square" rtlCol="0" anchor="ctr"/>
           <a:lstStyle/>
           <a:p>
-            <a:pPr marL="0" indent="0" algn="ctr">
+            <a:pPr algn="ctr" indent="0" marL="0">
               <a:buNone/>
             </a:pPr>
             <a:r>
@@ -11517,319 +10904,4 @@
     </a:ext>
   </a:extLst>
 </a:theme>
-</file>
-
-<file path=ppt/theme/theme2.xml><?xml version="1.0" encoding="utf-8"?>
-<a:theme xmlns:a="http://schemas.openxmlformats.org/drawingml/2006/main" name="Office Theme">
-  <a:themeElements>
-    <a:clrScheme name="Office">
-      <a:dk1>
-        <a:sysClr val="windowText" lastClr="000000"/>
-      </a:dk1>
-      <a:lt1>
-        <a:sysClr val="window" lastClr="FFFFFF"/>
-      </a:lt1>
-      <a:dk2>
-        <a:srgbClr val="0E2841"/>
-      </a:dk2>
-      <a:lt2>
-        <a:srgbClr val="E8E8E8"/>
-      </a:lt2>
-      <a:accent1>
-        <a:srgbClr val="156082"/>
-      </a:accent1>
-      <a:accent2>
-        <a:srgbClr val="E97132"/>
-      </a:accent2>
-      <a:accent3>
-        <a:srgbClr val="196B24"/>
-      </a:accent3>
-      <a:accent4>
-        <a:srgbClr val="0F9ED5"/>
-      </a:accent4>
-      <a:accent5>
-        <a:srgbClr val="A02B93"/>
-      </a:accent5>
-      <a:accent6>
-        <a:srgbClr val="4EA72E"/>
-      </a:accent6>
-      <a:hlink>
-        <a:srgbClr val="467886"/>
-      </a:hlink>
-      <a:folHlink>
-        <a:srgbClr val="96607D"/>
-      </a:folHlink>
-    </a:clrScheme>
-    <a:fontScheme name="Office">
-      <a:majorFont>
-        <a:latin typeface="Aptos Display" panose="02110004020202020204"/>
-        <a:ea typeface=""/>
-        <a:cs typeface=""/>
-        <a:font script="Jpan" typeface="游ゴシック Light"/>
-        <a:font script="Hang" typeface="맑은 고딕"/>
-        <a:font script="Hans" typeface="等线 Light"/>
-        <a:font script="Hant" typeface="新細明體"/>
-        <a:font script="Arab" typeface="Times New Roman"/>
-        <a:font script="Hebr" typeface="Times New Roman"/>
-        <a:font script="Thai" typeface="Angsana New"/>
-        <a:font script="Ethi" typeface="Nyala"/>
-        <a:font script="Beng" typeface="Vrinda"/>
-        <a:font script="Gujr" typeface="Shruti"/>
-        <a:font script="Khmr" typeface="MoolBoran"/>
-        <a:font script="Knda" typeface="Tunga"/>
-        <a:font script="Guru" typeface="Raavi"/>
-        <a:font script="Cans" typeface="Euphemia"/>
-        <a:font script="Cher" typeface="Plantagenet Cherokee"/>
-        <a:font script="Yiii" typeface="Microsoft Yi Baiti"/>
-        <a:font script="Tibt" typeface="Microsoft Himalaya"/>
-        <a:font script="Thaa" typeface="MV Boli"/>
-        <a:font script="Deva" typeface="Mangal"/>
-        <a:font script="Telu" typeface="Gautami"/>
-        <a:font script="Taml" typeface="Latha"/>
-        <a:font script="Syrc" typeface="Estrangelo Edessa"/>
-        <a:font script="Orya" typeface="Kalinga"/>
-        <a:font script="Mlym" typeface="Kartika"/>
-        <a:font script="Laoo" typeface="DokChampa"/>
-        <a:font script="Sinh" typeface="Iskoola Pota"/>
-        <a:font script="Mong" typeface="Mongolian Baiti"/>
-        <a:font script="Viet" typeface="Times New Roman"/>
-        <a:font script="Uigh" typeface="Microsoft Uighur"/>
-        <a:font script="Geor" typeface="Sylfaen"/>
-        <a:font script="Armn" typeface="Arial"/>
-        <a:font script="Bugi" typeface="Leelawadee UI"/>
-        <a:font script="Bopo" typeface="Microsoft JhengHei"/>
-        <a:font script="Java" typeface="Javanese Text"/>
-        <a:font script="Lisu" typeface="Segoe UI"/>
-        <a:font script="Mymr" typeface="Myanmar Text"/>
-        <a:font script="Nkoo" typeface="Ebrima"/>
-        <a:font script="Olck" typeface="Nirmala UI"/>
-        <a:font script="Osma" typeface="Ebrima"/>
-        <a:font script="Phag" typeface="Phagspa"/>
-        <a:font script="Syrn" typeface="Estrangelo Edessa"/>
-        <a:font script="Syrj" typeface="Estrangelo Edessa"/>
-        <a:font script="Syre" typeface="Estrangelo Edessa"/>
-        <a:font script="Sora" typeface="Nirmala UI"/>
-        <a:font script="Tale" typeface="Microsoft Tai Le"/>
-        <a:font script="Talu" typeface="Microsoft New Tai Lue"/>
-        <a:font script="Tfng" typeface="Ebrima"/>
-      </a:majorFont>
-      <a:minorFont>
-        <a:latin typeface="Aptos" panose="02110004020202020204"/>
-        <a:ea typeface=""/>
-        <a:cs typeface=""/>
-        <a:font script="Jpan" typeface="游ゴシック"/>
-        <a:font script="Hang" typeface="맑은 고딕"/>
-        <a:font script="Hans" typeface="等线"/>
-        <a:font script="Hant" typeface="新細明體"/>
-        <a:font script="Arab" typeface="Arial"/>
-        <a:font script="Hebr" typeface="Arial"/>
-        <a:font script="Thai" typeface="Cordia New"/>
-        <a:font script="Ethi" typeface="Nyala"/>
-        <a:font script="Beng" typeface="Vrinda"/>
-        <a:font script="Gujr" typeface="Shruti"/>
-        <a:font script="Khmr" typeface="DaunPenh"/>
-        <a:font script="Knda" typeface="Tunga"/>
-        <a:font script="Guru" typeface="Raavi"/>
-        <a:font script="Cans" typeface="Euphemia"/>
-        <a:font script="Cher" typeface="Plantagenet Cherokee"/>
-        <a:font script="Yiii" typeface="Microsoft Yi Baiti"/>
-        <a:font script="Tibt" typeface="Microsoft Himalaya"/>
-        <a:font script="Thaa" typeface="MV Boli"/>
-        <a:font script="Deva" typeface="Mangal"/>
-        <a:font script="Telu" typeface="Gautami"/>
-        <a:font script="Taml" typeface="Latha"/>
-        <a:font script="Syrc" typeface="Estrangelo Edessa"/>
-        <a:font script="Orya" typeface="Kalinga"/>
-        <a:font script="Mlym" typeface="Kartika"/>
-        <a:font script="Laoo" typeface="DokChampa"/>
-        <a:font script="Sinh" typeface="Iskoola Pota"/>
-        <a:font script="Mong" typeface="Mongolian Baiti"/>
-        <a:font script="Viet" typeface="Arial"/>
-        <a:font script="Uigh" typeface="Microsoft Uighur"/>
-        <a:font script="Geor" typeface="Sylfaen"/>
-        <a:font script="Armn" typeface="Arial"/>
-        <a:font script="Bugi" typeface="Leelawadee UI"/>
-        <a:font script="Bopo" typeface="Microsoft JhengHei"/>
-        <a:font script="Java" typeface="Javanese Text"/>
-        <a:font script="Lisu" typeface="Segoe UI"/>
-        <a:font script="Mymr" typeface="Myanmar Text"/>
-        <a:font script="Nkoo" typeface="Ebrima"/>
-        <a:font script="Olck" typeface="Nirmala UI"/>
-        <a:font script="Osma" typeface="Ebrima"/>
-        <a:font script="Phag" typeface="Phagspa"/>
-        <a:font script="Syrn" typeface="Estrangelo Edessa"/>
-        <a:font script="Syrj" typeface="Estrangelo Edessa"/>
-        <a:font script="Syre" typeface="Estrangelo Edessa"/>
-        <a:font script="Sora" typeface="Nirmala UI"/>
-        <a:font script="Tale" typeface="Microsoft Tai Le"/>
-        <a:font script="Talu" typeface="Microsoft New Tai Lue"/>
-        <a:font script="Tfng" typeface="Ebrima"/>
-      </a:minorFont>
-    </a:fontScheme>
-    <a:fmtScheme name="Office">
-      <a:fillStyleLst>
-        <a:solidFill>
-          <a:schemeClr val="phClr"/>
-        </a:solidFill>
-        <a:gradFill rotWithShape="1">
-          <a:gsLst>
-            <a:gs pos="0">
-              <a:schemeClr val="phClr">
-                <a:lumMod val="110000"/>
-                <a:satMod val="105000"/>
-                <a:tint val="67000"/>
-              </a:schemeClr>
-            </a:gs>
-            <a:gs pos="50000">
-              <a:schemeClr val="phClr">
-                <a:lumMod val="105000"/>
-                <a:satMod val="103000"/>
-                <a:tint val="73000"/>
-              </a:schemeClr>
-            </a:gs>
-            <a:gs pos="100000">
-              <a:schemeClr val="phClr">
-                <a:lumMod val="105000"/>
-                <a:satMod val="109000"/>
-                <a:tint val="81000"/>
-              </a:schemeClr>
-            </a:gs>
-          </a:gsLst>
-          <a:lin ang="5400000" scaled="0"/>
-        </a:gradFill>
-        <a:gradFill rotWithShape="1">
-          <a:gsLst>
-            <a:gs pos="0">
-              <a:schemeClr val="phClr">
-                <a:satMod val="103000"/>
-                <a:lumMod val="102000"/>
-                <a:tint val="94000"/>
-              </a:schemeClr>
-            </a:gs>
-            <a:gs pos="50000">
-              <a:schemeClr val="phClr">
-                <a:satMod val="110000"/>
-                <a:lumMod val="100000"/>
-                <a:shade val="100000"/>
-              </a:schemeClr>
-            </a:gs>
-            <a:gs pos="100000">
-              <a:schemeClr val="phClr">
-                <a:lumMod val="99000"/>
-                <a:satMod val="120000"/>
-                <a:shade val="78000"/>
-              </a:schemeClr>
-            </a:gs>
-          </a:gsLst>
-          <a:lin ang="5400000" scaled="0"/>
-        </a:gradFill>
-      </a:fillStyleLst>
-      <a:lnStyleLst>
-        <a:ln w="12700" cap="flat" cmpd="sng" algn="ctr">
-          <a:solidFill>
-            <a:schemeClr val="phClr"/>
-          </a:solidFill>
-          <a:prstDash val="solid"/>
-          <a:miter lim="800000"/>
-        </a:ln>
-        <a:ln w="19050" cap="flat" cmpd="sng" algn="ctr">
-          <a:solidFill>
-            <a:schemeClr val="phClr"/>
-          </a:solidFill>
-          <a:prstDash val="solid"/>
-          <a:miter lim="800000"/>
-        </a:ln>
-        <a:ln w="25400" cap="flat" cmpd="sng" algn="ctr">
-          <a:solidFill>
-            <a:schemeClr val="phClr"/>
-          </a:solidFill>
-          <a:prstDash val="solid"/>
-          <a:miter lim="800000"/>
-        </a:ln>
-      </a:lnStyleLst>
-      <a:effectStyleLst>
-        <a:effectStyle>
-          <a:effectLst/>
-        </a:effectStyle>
-        <a:effectStyle>
-          <a:effectLst/>
-        </a:effectStyle>
-        <a:effectStyle>
-          <a:effectLst>
-            <a:outerShdw blurRad="57150" dist="19050" dir="5400000" algn="ctr" rotWithShape="0">
-              <a:srgbClr val="000000">
-                <a:alpha val="63000"/>
-              </a:srgbClr>
-            </a:outerShdw>
-          </a:effectLst>
-        </a:effectStyle>
-      </a:effectStyleLst>
-      <a:bgFillStyleLst>
-        <a:solidFill>
-          <a:schemeClr val="phClr"/>
-        </a:solidFill>
-        <a:solidFill>
-          <a:schemeClr val="phClr">
-            <a:tint val="95000"/>
-            <a:satMod val="170000"/>
-          </a:schemeClr>
-        </a:solidFill>
-        <a:gradFill rotWithShape="1">
-          <a:gsLst>
-            <a:gs pos="0">
-              <a:schemeClr val="phClr">
-                <a:tint val="93000"/>
-                <a:satMod val="150000"/>
-                <a:shade val="98000"/>
-                <a:lumMod val="102000"/>
-              </a:schemeClr>
-            </a:gs>
-            <a:gs pos="50000">
-              <a:schemeClr val="phClr">
-                <a:tint val="98000"/>
-                <a:satMod val="130000"/>
-                <a:shade val="90000"/>
-                <a:lumMod val="103000"/>
-              </a:schemeClr>
-            </a:gs>
-            <a:gs pos="100000">
-              <a:schemeClr val="phClr">
-                <a:shade val="63000"/>
-                <a:satMod val="120000"/>
-              </a:schemeClr>
-            </a:gs>
-          </a:gsLst>
-          <a:lin ang="5400000" scaled="0"/>
-        </a:gradFill>
-      </a:bgFillStyleLst>
-    </a:fmtScheme>
-  </a:themeElements>
-  <a:objectDefaults>
-    <a:lnDef>
-      <a:spPr/>
-      <a:bodyPr/>
-      <a:lstStyle/>
-      <a:style>
-        <a:lnRef idx="2">
-          <a:schemeClr val="accent1"/>
-        </a:lnRef>
-        <a:fillRef idx="0">
-          <a:schemeClr val="accent1"/>
-        </a:fillRef>
-        <a:effectRef idx="1">
-          <a:schemeClr val="accent1"/>
-        </a:effectRef>
-        <a:fontRef idx="minor">
-          <a:schemeClr val="tx1"/>
-        </a:fontRef>
-      </a:style>
-    </a:lnDef>
-  </a:objectDefaults>
-  <a:extraClrSchemeLst/>
-  <a:extLst>
-    <a:ext uri="{05A4C25C-085E-4340-85A3-A5531E510DB2}">
-      <thm15:themeFamily xmlns:thm15="http://schemas.microsoft.com/office/thememl/2012/main" name="Office Theme" id="{2E142A2C-CD16-42D6-873A-C26D2A0506FA}" vid="{1BDDFF52-6CD6-40A5-AB3C-68EB2F1E4D0A}"/>
-    </a:ext>
-  </a:extLst>
-</a:theme>
 </file>
</xml_diff>